<commit_message>
Definitions, record tile heads, Fixed Ops DOC, total variance marks, Before You Leave prompts
Co-Authored-By: Claude Opus 5.5 <noreply@anthropic.com>
Claude-Session: https://claude.ai/code/session_01Xa4nFVxuQGXmHARGph9WhS
</commit_message>
<xml_diff>
--- a/day2-deck/decks/Fixed Absorption & Net Profit - House Style.pptx
+++ b/day2-deck/decks/Fixed Absorption & Net Profit - House Style.pptx
@@ -3518,7 +3518,7 @@
               <a:buNone/>
             </a:pPr>
             <a:r>
-              <a:rPr lang="en-US" sz="1400" dirty="0">
+              <a:rPr lang="en-US" sz="1500" dirty="0">
                 <a:solidFill>
                   <a:srgbClr val="595959"/>
                 </a:solidFill>
@@ -3526,9 +3526,9 @@
                 <a:ea typeface="Inter" pitchFamily="34" charset="-122"/>
                 <a:cs typeface="Inter" pitchFamily="34" charset="-120"/>
               </a:rPr>
-              <a:t>How much of the whole store's fixed expenses, not just service and parts expenses, the service and parts gross pays for.</a:t>
-            </a:r>
-            <a:endParaRPr lang="en-US" sz="1400" dirty="0"/>
+              <a:t>How much of the dealership's fixed expenses are covered by parts and service gross profit.</a:t>
+            </a:r>
+            <a:endParaRPr lang="en-US" sz="1500" dirty="0"/>
           </a:p>
         </p:txBody>
       </p:sp>
@@ -5461,7 +5461,7 @@
                 <a:ea typeface="Inter" pitchFamily="34" charset="-122"/>
                 <a:cs typeface="Inter" pitchFamily="34" charset="-120"/>
               </a:rPr>
-              <a:t>What service and parts keep after paying their own people, building, systems and supplies.</a:t>
+              <a:t>The profit parts and service generate after their allocated expenses are covered.</a:t>
             </a:r>
             <a:endParaRPr lang="en-US" sz="1500" dirty="0"/>
           </a:p>

</xml_diff>

<commit_message>
Explainer titles: drop 'What Is ... ?'
Co-Authored-By: Claude Opus 5.5 <noreply@anthropic.com>
Claude-Session: https://claude.ai/code/session_01Xa4nFVxuQGXmHARGph9WhS
</commit_message>
<xml_diff>
--- a/day2-deck/decks/Fixed Absorption & Net Profit - House Style.pptx
+++ b/day2-deck/decks/Fixed Absorption & Net Profit - House Style.pptx
@@ -3370,7 +3370,7 @@
                 <a:ea typeface="Inter" pitchFamily="34" charset="-122"/>
                 <a:cs typeface="Inter" pitchFamily="34" charset="-120"/>
               </a:rPr>
-              <a:t>What Is Fixed Absorption?</a:t>
+              <a:t>Fixed Absorption</a:t>
             </a:r>
             <a:endParaRPr lang="en-US" sz="2800" dirty="0"/>
           </a:p>
@@ -4421,7 +4421,7 @@
                 <a:ea typeface="Inter" pitchFamily="34" charset="-122"/>
                 <a:cs typeface="Inter" pitchFamily="34" charset="-120"/>
               </a:rPr>
-              <a:t>What Is in Total Store Fixed Expenses?</a:t>
+              <a:t>Total Store Fixed Expenses</a:t>
             </a:r>
             <a:endParaRPr lang="en-US" sz="2800" dirty="0"/>
           </a:p>
@@ -5305,7 +5305,7 @@
                 <a:ea typeface="Inter" pitchFamily="34" charset="-122"/>
                 <a:cs typeface="Inter" pitchFamily="34" charset="-120"/>
               </a:rPr>
-              <a:t>What Is Fixed Ops Net Profit?</a:t>
+              <a:t>Fixed Ops Net Profit</a:t>
             </a:r>
             <a:endParaRPr lang="en-US" sz="2800" dirty="0"/>
           </a:p>

</xml_diff>

<commit_message>
Clocked-hours proficiency wording, turnaround blue bar in the deck, INEOS/body shop decision recorded
Co-Authored-By: Claude Opus 5.5 <noreply@anthropic.com>
Claude-Session: https://claude.ai/code/session_01Xa4nFVxuQGXmHARGph9WhS
</commit_message>
<xml_diff>
--- a/day2-deck/decks/Fixed Absorption & Net Profit - House Style.pptx
+++ b/day2-deck/decks/Fixed Absorption & Net Profit - House Style.pptx
@@ -19916,7 +19916,27 @@
       </p:sp>
       <p:sp>
         <p:nvSpPr>
-          <p:cNvPr id="33" name="Text 31"/>
+          <p:cNvPr id="33" name="Shape 31"/>
+          <p:cNvSpPr/>
+          <p:nvPr/>
+        </p:nvSpPr>
+        <p:spPr>
+          <a:xfrm>
+            <a:off x="7775448" y="2139696"/>
+            <a:ext cx="64008" cy="755294"/>
+          </a:xfrm>
+          <a:prstGeom prst="rect">
+            <a:avLst/>
+          </a:prstGeom>
+          <a:solidFill>
+            <a:srgbClr val="2587C5"/>
+          </a:solidFill>
+          <a:ln/>
+        </p:spPr>
+      </p:sp>
+      <p:sp>
+        <p:nvSpPr>
+          <p:cNvPr id="34" name="Text 32"/>
           <p:cNvSpPr txBox="1"/>
           <p:nvPr/>
         </p:nvSpPr>
@@ -19955,7 +19975,7 @@
       </p:sp>
       <p:sp>
         <p:nvSpPr>
-          <p:cNvPr id="34" name="Text 32"/>
+          <p:cNvPr id="35" name="Text 33"/>
           <p:cNvSpPr txBox="1"/>
           <p:nvPr/>
         </p:nvSpPr>
@@ -20034,7 +20054,7 @@
       </p:sp>
       <p:sp>
         <p:nvSpPr>
-          <p:cNvPr id="35" name="Text 33"/>
+          <p:cNvPr id="36" name="Text 34"/>
           <p:cNvSpPr txBox="1"/>
           <p:nvPr/>
         </p:nvSpPr>
@@ -20073,7 +20093,7 @@
       </p:sp>
       <p:sp>
         <p:nvSpPr>
-          <p:cNvPr id="36" name="Text 34"/>
+          <p:cNvPr id="37" name="Text 35"/>
           <p:cNvSpPr txBox="1"/>
           <p:nvPr/>
         </p:nvSpPr>
@@ -20112,7 +20132,7 @@
       </p:sp>
       <p:sp>
         <p:nvSpPr>
-          <p:cNvPr id="37" name="Text 35"/>
+          <p:cNvPr id="38" name="Text 36"/>
           <p:cNvSpPr txBox="1"/>
           <p:nvPr/>
         </p:nvSpPr>
@@ -20191,7 +20211,7 @@
       </p:sp>
       <p:sp>
         <p:nvSpPr>
-          <p:cNvPr id="38" name="Text 36"/>
+          <p:cNvPr id="39" name="Text 37"/>
           <p:cNvSpPr txBox="1"/>
           <p:nvPr/>
         </p:nvSpPr>
@@ -20230,7 +20250,7 @@
       </p:sp>
       <p:sp>
         <p:nvSpPr>
-          <p:cNvPr id="39" name="Shape 37"/>
+          <p:cNvPr id="40" name="Shape 38"/>
           <p:cNvSpPr/>
           <p:nvPr/>
         </p:nvSpPr>
@@ -20250,7 +20270,7 @@
       </p:sp>
       <p:sp>
         <p:nvSpPr>
-          <p:cNvPr id="40" name="Text 38"/>
+          <p:cNvPr id="41" name="Text 39"/>
           <p:cNvSpPr txBox="1"/>
           <p:nvPr/>
         </p:nvSpPr>
@@ -20289,7 +20309,7 @@
       </p:sp>
       <p:sp>
         <p:nvSpPr>
-          <p:cNvPr id="41" name="Text 39"/>
+          <p:cNvPr id="42" name="Text 40"/>
           <p:cNvSpPr txBox="1"/>
           <p:nvPr/>
         </p:nvSpPr>
@@ -20368,7 +20388,7 @@
       </p:sp>
       <p:sp>
         <p:nvSpPr>
-          <p:cNvPr id="42" name="Text 40"/>
+          <p:cNvPr id="43" name="Text 41"/>
           <p:cNvSpPr txBox="1"/>
           <p:nvPr/>
         </p:nvSpPr>
@@ -20407,7 +20427,7 @@
       </p:sp>
       <p:sp>
         <p:nvSpPr>
-          <p:cNvPr id="43" name="Text 41"/>
+          <p:cNvPr id="44" name="Text 42"/>
           <p:cNvSpPr txBox="1"/>
           <p:nvPr/>
         </p:nvSpPr>
@@ -20446,7 +20466,7 @@
       </p:sp>
       <p:sp>
         <p:nvSpPr>
-          <p:cNvPr id="44" name="Text 42"/>
+          <p:cNvPr id="45" name="Text 43"/>
           <p:cNvSpPr txBox="1"/>
           <p:nvPr/>
         </p:nvSpPr>
@@ -20525,7 +20545,7 @@
       </p:sp>
       <p:sp>
         <p:nvSpPr>
-          <p:cNvPr id="45" name="Text 43"/>
+          <p:cNvPr id="46" name="Text 44"/>
           <p:cNvSpPr txBox="1"/>
           <p:nvPr/>
         </p:nvSpPr>
@@ -20564,7 +20584,7 @@
       </p:sp>
       <p:sp>
         <p:nvSpPr>
-          <p:cNvPr id="46" name="Shape 44"/>
+          <p:cNvPr id="47" name="Shape 45"/>
           <p:cNvSpPr/>
           <p:nvPr/>
         </p:nvSpPr>
@@ -20584,7 +20604,7 @@
       </p:sp>
       <p:sp>
         <p:nvSpPr>
-          <p:cNvPr id="47" name="Text 45"/>
+          <p:cNvPr id="48" name="Text 46"/>
           <p:cNvSpPr txBox="1"/>
           <p:nvPr/>
         </p:nvSpPr>
@@ -20623,7 +20643,7 @@
       </p:sp>
       <p:sp>
         <p:nvSpPr>
-          <p:cNvPr id="48" name="Text 46"/>
+          <p:cNvPr id="49" name="Text 47"/>
           <p:cNvSpPr txBox="1"/>
           <p:nvPr/>
         </p:nvSpPr>
@@ -20702,7 +20722,7 @@
       </p:sp>
       <p:sp>
         <p:nvSpPr>
-          <p:cNvPr id="49" name="Text 47"/>
+          <p:cNvPr id="50" name="Text 48"/>
           <p:cNvSpPr txBox="1"/>
           <p:nvPr/>
         </p:nvSpPr>
@@ -20741,7 +20761,7 @@
       </p:sp>
       <p:sp>
         <p:nvSpPr>
-          <p:cNvPr id="50" name="Shape 48"/>
+          <p:cNvPr id="51" name="Shape 49"/>
           <p:cNvSpPr/>
           <p:nvPr/>
         </p:nvSpPr>
@@ -20761,7 +20781,7 @@
       </p:sp>
       <p:sp>
         <p:nvSpPr>
-          <p:cNvPr id="51" name="Text 49"/>
+          <p:cNvPr id="52" name="Text 50"/>
           <p:cNvSpPr txBox="1"/>
           <p:nvPr/>
         </p:nvSpPr>
@@ -20800,7 +20820,7 @@
       </p:sp>
       <p:sp>
         <p:nvSpPr>
-          <p:cNvPr id="52" name="Text 50"/>
+          <p:cNvPr id="53" name="Text 51"/>
           <p:cNvSpPr txBox="1"/>
           <p:nvPr/>
         </p:nvSpPr>
@@ -20839,7 +20859,7 @@
       </p:sp>
       <p:sp>
         <p:nvSpPr>
-          <p:cNvPr id="53" name="Shape 51"/>
+          <p:cNvPr id="54" name="Shape 52"/>
           <p:cNvSpPr/>
           <p:nvPr/>
         </p:nvSpPr>
@@ -20859,7 +20879,7 @@
       </p:sp>
       <p:sp>
         <p:nvSpPr>
-          <p:cNvPr id="54" name="Shape 52"/>
+          <p:cNvPr id="55" name="Shape 53"/>
           <p:cNvSpPr/>
           <p:nvPr/>
         </p:nvSpPr>
@@ -20879,7 +20899,7 @@
       </p:sp>
       <p:sp>
         <p:nvSpPr>
-          <p:cNvPr id="55" name="Text 53"/>
+          <p:cNvPr id="56" name="Text 54"/>
           <p:cNvSpPr txBox="1"/>
           <p:nvPr/>
         </p:nvSpPr>
@@ -20918,7 +20938,7 @@
       </p:sp>
       <p:sp>
         <p:nvSpPr>
-          <p:cNvPr id="56" name="Text 54"/>
+          <p:cNvPr id="57" name="Text 55"/>
           <p:cNvSpPr txBox="1"/>
           <p:nvPr/>
         </p:nvSpPr>
@@ -20997,7 +21017,7 @@
       </p:sp>
       <p:sp>
         <p:nvSpPr>
-          <p:cNvPr id="57" name="Text 55"/>
+          <p:cNvPr id="58" name="Text 56"/>
           <p:cNvSpPr txBox="1"/>
           <p:nvPr/>
         </p:nvSpPr>
@@ -21036,7 +21056,7 @@
       </p:sp>
       <p:sp>
         <p:nvSpPr>
-          <p:cNvPr id="58" name="Shape 56"/>
+          <p:cNvPr id="59" name="Shape 57"/>
           <p:cNvSpPr/>
           <p:nvPr/>
         </p:nvSpPr>
@@ -21056,7 +21076,7 @@
       </p:sp>
       <p:sp>
         <p:nvSpPr>
-          <p:cNvPr id="59" name="Text 57"/>
+          <p:cNvPr id="60" name="Text 58"/>
           <p:cNvSpPr txBox="1"/>
           <p:nvPr/>
         </p:nvSpPr>
@@ -21095,7 +21115,7 @@
       </p:sp>
       <p:sp>
         <p:nvSpPr>
-          <p:cNvPr id="60" name="Text 58"/>
+          <p:cNvPr id="61" name="Text 59"/>
           <p:cNvSpPr txBox="1"/>
           <p:nvPr/>
         </p:nvSpPr>
@@ -21174,7 +21194,7 @@
       </p:sp>
       <p:sp>
         <p:nvSpPr>
-          <p:cNvPr id="61" name="Text 59"/>
+          <p:cNvPr id="62" name="Text 60"/>
           <p:cNvSpPr txBox="1"/>
           <p:nvPr/>
         </p:nvSpPr>
@@ -21213,7 +21233,7 @@
       </p:sp>
       <p:sp>
         <p:nvSpPr>
-          <p:cNvPr id="62" name="Shape 60"/>
+          <p:cNvPr id="63" name="Shape 61"/>
           <p:cNvSpPr/>
           <p:nvPr/>
         </p:nvSpPr>
@@ -21233,7 +21253,27 @@
       </p:sp>
       <p:sp>
         <p:nvSpPr>
-          <p:cNvPr id="63" name="Text 61"/>
+          <p:cNvPr id="64" name="Shape 62"/>
+          <p:cNvSpPr/>
+          <p:nvPr/>
+        </p:nvSpPr>
+        <p:spPr>
+          <a:xfrm>
+            <a:off x="11466576" y="3796589"/>
+            <a:ext cx="64008" cy="755294"/>
+          </a:xfrm>
+          <a:prstGeom prst="rect">
+            <a:avLst/>
+          </a:prstGeom>
+          <a:solidFill>
+            <a:srgbClr val="2587C5"/>
+          </a:solidFill>
+          <a:ln/>
+        </p:spPr>
+      </p:sp>
+      <p:sp>
+        <p:nvSpPr>
+          <p:cNvPr id="65" name="Text 63"/>
           <p:cNvSpPr txBox="1"/>
           <p:nvPr/>
         </p:nvSpPr>
@@ -21272,7 +21312,7 @@
       </p:sp>
       <p:sp>
         <p:nvSpPr>
-          <p:cNvPr id="64" name="Text 62"/>
+          <p:cNvPr id="66" name="Text 64"/>
           <p:cNvSpPr txBox="1"/>
           <p:nvPr/>
         </p:nvSpPr>
@@ -21351,7 +21391,7 @@
       </p:sp>
       <p:sp>
         <p:nvSpPr>
-          <p:cNvPr id="65" name="Text 63"/>
+          <p:cNvPr id="67" name="Text 65"/>
           <p:cNvSpPr txBox="1"/>
           <p:nvPr/>
         </p:nvSpPr>
@@ -21390,7 +21430,7 @@
       </p:sp>
       <p:sp>
         <p:nvSpPr>
-          <p:cNvPr id="66" name="Text 64"/>
+          <p:cNvPr id="68" name="Text 66"/>
           <p:cNvSpPr txBox="1"/>
           <p:nvPr/>
         </p:nvSpPr>
@@ -21429,7 +21469,7 @@
       </p:sp>
       <p:sp>
         <p:nvSpPr>
-          <p:cNvPr id="67" name="Text 65"/>
+          <p:cNvPr id="69" name="Text 67"/>
           <p:cNvSpPr txBox="1"/>
           <p:nvPr/>
         </p:nvSpPr>
@@ -21508,7 +21548,7 @@
       </p:sp>
       <p:sp>
         <p:nvSpPr>
-          <p:cNvPr id="68" name="Text 66"/>
+          <p:cNvPr id="70" name="Text 68"/>
           <p:cNvSpPr txBox="1"/>
           <p:nvPr/>
         </p:nvSpPr>
@@ -21547,7 +21587,7 @@
       </p:sp>
       <p:sp>
         <p:nvSpPr>
-          <p:cNvPr id="69" name="Shape 67"/>
+          <p:cNvPr id="71" name="Shape 69"/>
           <p:cNvSpPr/>
           <p:nvPr/>
         </p:nvSpPr>
@@ -21567,7 +21607,7 @@
       </p:sp>
       <p:sp>
         <p:nvSpPr>
-          <p:cNvPr id="70" name="Text 68"/>
+          <p:cNvPr id="72" name="Text 70"/>
           <p:cNvSpPr txBox="1"/>
           <p:nvPr/>
         </p:nvSpPr>
@@ -21606,7 +21646,7 @@
       </p:sp>
       <p:sp>
         <p:nvSpPr>
-          <p:cNvPr id="71" name="Text 69"/>
+          <p:cNvPr id="73" name="Text 71"/>
           <p:cNvSpPr txBox="1"/>
           <p:nvPr/>
         </p:nvSpPr>
@@ -21685,7 +21725,7 @@
       </p:sp>
       <p:sp>
         <p:nvSpPr>
-          <p:cNvPr id="72" name="Text 70"/>
+          <p:cNvPr id="74" name="Text 72"/>
           <p:cNvSpPr txBox="1"/>
           <p:nvPr/>
         </p:nvSpPr>

</xml_diff>

<commit_message>
Net profit and record year bands: no store asks, clearer 24 of 33
Co-Authored-By: Claude Opus 5.5 <noreply@anthropic.com>
Claude-Session: https://claude.ai/code/session_01Xa4nFVxuQGXmHARGph9WhS
</commit_message>
<xml_diff>
--- a/day2-deck/decks/Fixed Absorption & Net Profit - House Style.pptx
+++ b/day2-deck/decks/Fixed Absorption & Net Profit - House Style.pptx
@@ -2729,7 +2729,7 @@
           <a:p>
             <a:r>
               <a:rPr lang="en-US" dirty="0"/>
-              <a:t>Takeaway with the store call-outs (off the slide): Toyota Henderson leads at $7.83M of the group's $50.45M. 2 stores are losing money in fixed ops, Hyundai Prescott the most at −$136,511.Source: Qlik - Profit &amp; Loss, Detail statement. Same-store, INEOS excluded (opened 2026). Fixed ops net profit = service (Mechanical) + parts (P&amp;A) department profit: department gross less the department's own expenses; GMC Prescott body shop is its own department and is not included. Jan-Sep 2026.</a:t>
+              <a:t>Source: Qlik - Profit &amp; Loss, Detail statement. Same-store, INEOS excluded (opened 2026). Fixed ops net profit = service (Mechanical) + parts (P&amp;A) department profit: department gross less the department's own expenses; GMC Prescott body shop is its own department and is not included. Jan-Sep 2026.</a:t>
             </a:r>
             <a:endParaRPr lang="en-US" dirty="0"/>
           </a:p>
@@ -2817,7 +2817,7 @@
           <a:p>
             <a:r>
               <a:rPr lang="en-US" dirty="0"/>
-              <a:t>Takeaway with the store call-outs (off the slide): Lincoln, Subaru Prescott and GMC Prescott turned a 2025 loss into a profit (green rows); VW St George went from a profit to a loss (red row). 24 of 33 stores grew.Source: Qlik - Profit &amp; Loss, Detail statement. Same-store, INEOS excluded (opened 2026). Fixed ops net profit = service (Mechanical) + parts (P&amp;A) department profit: department gross less the department's own expenses; GMC Prescott body shop is its own department and is not included. Ranked by dollar change, Jan-Sep 2026 vs Jan-Sep 2025; percent change alongside, top three and bottom three by percent marked. Percent change = dollar change / 2025 profit; where 2025 was a loss, divided by the size of the loss, so an improvement reads as positive.Green band: lost money in fixed ops in 2025, made money in 2026 (Lincoln −$389K to $94K, Subaru Prescott −$55K to $129K and GMC Prescott −$125K to $20K). Red band: made money in 2025, lost money in 2026 (VW St George $153K to −$59K).</a:t>
+              <a:t>Takeaway with the store call-outs (off the slide): Lincoln, Subaru Prescott and GMC Prescott turned a 2025 loss into a profit (green rows); VW St George went from a profit to a loss (red row). 24 of 33 stores grew fixed ops net profit, January through September year to date.Source: Qlik - Profit &amp; Loss, Detail statement. Same-store, INEOS excluded (opened 2026). Fixed ops net profit = service (Mechanical) + parts (P&amp;A) department profit: department gross less the department's own expenses; GMC Prescott body shop is its own department and is not included. Ranked by dollar change, Jan-Sep 2026 vs Jan-Sep 2025; percent change alongside, top three and bottom three by percent marked. Percent change = dollar change / 2025 profit; where 2025 was a loss, divided by the size of the loss, so an improvement reads as positive.Green band: lost money in fixed ops in 2025, made money in 2026 (Lincoln −$389K to $94K, Subaru Prescott −$55K to $129K and GMC Prescott −$125K to $20K). Red band: made money in 2025, lost money in 2026 (VW St George $153K to −$59K).</a:t>
             </a:r>
             <a:endParaRPr lang="en-US" dirty="0"/>
           </a:p>
@@ -7305,7 +7305,7 @@
         <p:spPr>
           <a:xfrm>
             <a:off x="457200" y="1207008"/>
-            <a:ext cx="11274552" cy="4782312"/>
+            <a:ext cx="11274552" cy="5148072"/>
           </a:xfrm>
           <a:prstGeom prst="rect">
             <a:avLst/>
@@ -7482,7 +7482,7 @@
         <p:spPr>
           <a:xfrm>
             <a:off x="658368" y="1847088"/>
-            <a:ext cx="310896" cy="239896"/>
+            <a:ext cx="310896" cy="261411"/>
           </a:xfrm>
           <a:prstGeom prst="rect">
             <a:avLst/>
@@ -7521,7 +7521,7 @@
         <p:spPr>
           <a:xfrm>
             <a:off x="1014984" y="1847088"/>
-            <a:ext cx="1920240" cy="239896"/>
+            <a:ext cx="1920240" cy="261411"/>
           </a:xfrm>
           <a:prstGeom prst="rect">
             <a:avLst/>
@@ -7559,8 +7559,8 @@
         </p:nvSpPr>
         <p:spPr>
           <a:xfrm>
-            <a:off x="2980944" y="1911860"/>
-            <a:ext cx="1828800" cy="110352"/>
+            <a:off x="2980944" y="1917669"/>
+            <a:ext cx="1828800" cy="120249"/>
           </a:xfrm>
           <a:prstGeom prst="rect">
             <a:avLst/>
@@ -7580,7 +7580,7 @@
         <p:spPr>
           <a:xfrm>
             <a:off x="4855464" y="1847088"/>
-            <a:ext cx="1097280" cy="239896"/>
+            <a:ext cx="1097280" cy="261411"/>
           </a:xfrm>
           <a:prstGeom prst="rect">
             <a:avLst/>
@@ -7618,8 +7618,8 @@
         </p:nvSpPr>
         <p:spPr>
           <a:xfrm>
-            <a:off x="658368" y="2086984"/>
-            <a:ext cx="310896" cy="239896"/>
+            <a:off x="658368" y="2108499"/>
+            <a:ext cx="310896" cy="261411"/>
           </a:xfrm>
           <a:prstGeom prst="rect">
             <a:avLst/>
@@ -7657,8 +7657,8 @@
         </p:nvSpPr>
         <p:spPr>
           <a:xfrm>
-            <a:off x="1014984" y="2086984"/>
-            <a:ext cx="1920240" cy="239896"/>
+            <a:off x="1014984" y="2108499"/>
+            <a:ext cx="1920240" cy="261411"/>
           </a:xfrm>
           <a:prstGeom prst="rect">
             <a:avLst/>
@@ -7696,8 +7696,8 @@
         </p:nvSpPr>
         <p:spPr>
           <a:xfrm>
-            <a:off x="2980944" y="2151755"/>
-            <a:ext cx="1419699" cy="110352"/>
+            <a:off x="2980944" y="2179080"/>
+            <a:ext cx="1419699" cy="120249"/>
           </a:xfrm>
           <a:prstGeom prst="rect">
             <a:avLst/>
@@ -7716,8 +7716,8 @@
         </p:nvSpPr>
         <p:spPr>
           <a:xfrm>
-            <a:off x="4855464" y="2086984"/>
-            <a:ext cx="1097280" cy="239896"/>
+            <a:off x="4855464" y="2108499"/>
+            <a:ext cx="1097280" cy="261411"/>
           </a:xfrm>
           <a:prstGeom prst="rect">
             <a:avLst/>
@@ -7755,8 +7755,8 @@
         </p:nvSpPr>
         <p:spPr>
           <a:xfrm>
-            <a:off x="658368" y="2326879"/>
-            <a:ext cx="310896" cy="239896"/>
+            <a:off x="658368" y="2369910"/>
+            <a:ext cx="310896" cy="261411"/>
           </a:xfrm>
           <a:prstGeom prst="rect">
             <a:avLst/>
@@ -7794,8 +7794,8 @@
         </p:nvSpPr>
         <p:spPr>
           <a:xfrm>
-            <a:off x="1014984" y="2326879"/>
-            <a:ext cx="1920240" cy="239896"/>
+            <a:off x="1014984" y="2369910"/>
+            <a:ext cx="1920240" cy="261411"/>
           </a:xfrm>
           <a:prstGeom prst="rect">
             <a:avLst/>
@@ -7833,8 +7833,8 @@
         </p:nvSpPr>
         <p:spPr>
           <a:xfrm>
-            <a:off x="2980944" y="2391651"/>
-            <a:ext cx="1154907" cy="110352"/>
+            <a:off x="2980944" y="2440491"/>
+            <a:ext cx="1154907" cy="120249"/>
           </a:xfrm>
           <a:prstGeom prst="rect">
             <a:avLst/>
@@ -7853,8 +7853,8 @@
         </p:nvSpPr>
         <p:spPr>
           <a:xfrm>
-            <a:off x="4855464" y="2326879"/>
-            <a:ext cx="1097280" cy="239896"/>
+            <a:off x="4855464" y="2369910"/>
+            <a:ext cx="1097280" cy="261411"/>
           </a:xfrm>
           <a:prstGeom prst="rect">
             <a:avLst/>
@@ -7892,8 +7892,8 @@
         </p:nvSpPr>
         <p:spPr>
           <a:xfrm>
-            <a:off x="658368" y="2566775"/>
-            <a:ext cx="310896" cy="239896"/>
+            <a:off x="658368" y="2631320"/>
+            <a:ext cx="310896" cy="261411"/>
           </a:xfrm>
           <a:prstGeom prst="rect">
             <a:avLst/>
@@ -7931,8 +7931,8 @@
         </p:nvSpPr>
         <p:spPr>
           <a:xfrm>
-            <a:off x="1014984" y="2566775"/>
-            <a:ext cx="1920240" cy="239896"/>
+            <a:off x="1014984" y="2631320"/>
+            <a:ext cx="1920240" cy="261411"/>
           </a:xfrm>
           <a:prstGeom prst="rect">
             <a:avLst/>
@@ -7970,8 +7970,8 @@
         </p:nvSpPr>
         <p:spPr>
           <a:xfrm>
-            <a:off x="2980944" y="2631546"/>
-            <a:ext cx="775885" cy="110352"/>
+            <a:off x="2980944" y="2701901"/>
+            <a:ext cx="775885" cy="120249"/>
           </a:xfrm>
           <a:prstGeom prst="rect">
             <a:avLst/>
@@ -7990,8 +7990,8 @@
         </p:nvSpPr>
         <p:spPr>
           <a:xfrm>
-            <a:off x="4855464" y="2566775"/>
-            <a:ext cx="1097280" cy="239896"/>
+            <a:off x="4855464" y="2631320"/>
+            <a:ext cx="1097280" cy="261411"/>
           </a:xfrm>
           <a:prstGeom prst="rect">
             <a:avLst/>
@@ -8029,8 +8029,8 @@
         </p:nvSpPr>
         <p:spPr>
           <a:xfrm>
-            <a:off x="658368" y="2806670"/>
-            <a:ext cx="310896" cy="239896"/>
+            <a:off x="658368" y="2892731"/>
+            <a:ext cx="310896" cy="261411"/>
           </a:xfrm>
           <a:prstGeom prst="rect">
             <a:avLst/>
@@ -8068,8 +8068,8 @@
         </p:nvSpPr>
         <p:spPr>
           <a:xfrm>
-            <a:off x="1014984" y="2806670"/>
-            <a:ext cx="1920240" cy="239896"/>
+            <a:off x="1014984" y="2892731"/>
+            <a:ext cx="1920240" cy="261411"/>
           </a:xfrm>
           <a:prstGeom prst="rect">
             <a:avLst/>
@@ -8107,8 +8107,8 @@
         </p:nvSpPr>
         <p:spPr>
           <a:xfrm>
-            <a:off x="2980944" y="2871442"/>
-            <a:ext cx="686722" cy="110352"/>
+            <a:off x="2980944" y="2963312"/>
+            <a:ext cx="686722" cy="120249"/>
           </a:xfrm>
           <a:prstGeom prst="rect">
             <a:avLst/>
@@ -8127,8 +8127,8 @@
         </p:nvSpPr>
         <p:spPr>
           <a:xfrm>
-            <a:off x="4855464" y="2806670"/>
-            <a:ext cx="1097280" cy="239896"/>
+            <a:off x="4855464" y="2892731"/>
+            <a:ext cx="1097280" cy="261411"/>
           </a:xfrm>
           <a:prstGeom prst="rect">
             <a:avLst/>
@@ -8166,8 +8166,8 @@
         </p:nvSpPr>
         <p:spPr>
           <a:xfrm>
-            <a:off x="658368" y="3046566"/>
-            <a:ext cx="310896" cy="239896"/>
+            <a:off x="658368" y="3154142"/>
+            <a:ext cx="310896" cy="261411"/>
           </a:xfrm>
           <a:prstGeom prst="rect">
             <a:avLst/>
@@ -8205,8 +8205,8 @@
         </p:nvSpPr>
         <p:spPr>
           <a:xfrm>
-            <a:off x="1014984" y="3046566"/>
-            <a:ext cx="1920240" cy="239896"/>
+            <a:off x="1014984" y="3154142"/>
+            <a:ext cx="1920240" cy="261411"/>
           </a:xfrm>
           <a:prstGeom prst="rect">
             <a:avLst/>
@@ -8244,8 +8244,8 @@
         </p:nvSpPr>
         <p:spPr>
           <a:xfrm>
-            <a:off x="2980944" y="3111337"/>
-            <a:ext cx="606903" cy="110352"/>
+            <a:off x="2980944" y="3224723"/>
+            <a:ext cx="606903" cy="120249"/>
           </a:xfrm>
           <a:prstGeom prst="rect">
             <a:avLst/>
@@ -8264,8 +8264,8 @@
         </p:nvSpPr>
         <p:spPr>
           <a:xfrm>
-            <a:off x="4855464" y="3046566"/>
-            <a:ext cx="1097280" cy="239896"/>
+            <a:off x="4855464" y="3154142"/>
+            <a:ext cx="1097280" cy="261411"/>
           </a:xfrm>
           <a:prstGeom prst="rect">
             <a:avLst/>
@@ -8303,8 +8303,8 @@
         </p:nvSpPr>
         <p:spPr>
           <a:xfrm>
-            <a:off x="658368" y="3286461"/>
-            <a:ext cx="310896" cy="239896"/>
+            <a:off x="658368" y="3415553"/>
+            <a:ext cx="310896" cy="261411"/>
           </a:xfrm>
           <a:prstGeom prst="rect">
             <a:avLst/>
@@ -8342,8 +8342,8 @@
         </p:nvSpPr>
         <p:spPr>
           <a:xfrm>
-            <a:off x="1014984" y="3286461"/>
-            <a:ext cx="1920240" cy="239896"/>
+            <a:off x="1014984" y="3415553"/>
+            <a:ext cx="1920240" cy="261411"/>
           </a:xfrm>
           <a:prstGeom prst="rect">
             <a:avLst/>
@@ -8381,8 +8381,8 @@
         </p:nvSpPr>
         <p:spPr>
           <a:xfrm>
-            <a:off x="2980944" y="3351233"/>
-            <a:ext cx="529462" cy="110352"/>
+            <a:off x="2980944" y="3486134"/>
+            <a:ext cx="529462" cy="120249"/>
           </a:xfrm>
           <a:prstGeom prst="rect">
             <a:avLst/>
@@ -8401,8 +8401,8 @@
         </p:nvSpPr>
         <p:spPr>
           <a:xfrm>
-            <a:off x="4855464" y="3286461"/>
-            <a:ext cx="1097280" cy="239896"/>
+            <a:off x="4855464" y="3415553"/>
+            <a:ext cx="1097280" cy="261411"/>
           </a:xfrm>
           <a:prstGeom prst="rect">
             <a:avLst/>
@@ -8440,8 +8440,8 @@
         </p:nvSpPr>
         <p:spPr>
           <a:xfrm>
-            <a:off x="658368" y="3526357"/>
-            <a:ext cx="310896" cy="239896"/>
+            <a:off x="658368" y="3676964"/>
+            <a:ext cx="310896" cy="261411"/>
           </a:xfrm>
           <a:prstGeom prst="rect">
             <a:avLst/>
@@ -8479,8 +8479,8 @@
         </p:nvSpPr>
         <p:spPr>
           <a:xfrm>
-            <a:off x="1014984" y="3526357"/>
-            <a:ext cx="1920240" cy="239896"/>
+            <a:off x="1014984" y="3676964"/>
+            <a:ext cx="1920240" cy="261411"/>
           </a:xfrm>
           <a:prstGeom prst="rect">
             <a:avLst/>
@@ -8518,8 +8518,8 @@
         </p:nvSpPr>
         <p:spPr>
           <a:xfrm>
-            <a:off x="2980944" y="3591128"/>
-            <a:ext cx="477227" cy="110352"/>
+            <a:off x="2980944" y="3747545"/>
+            <a:ext cx="477227" cy="120249"/>
           </a:xfrm>
           <a:prstGeom prst="rect">
             <a:avLst/>
@@ -8538,8 +8538,8 @@
         </p:nvSpPr>
         <p:spPr>
           <a:xfrm>
-            <a:off x="4855464" y="3526357"/>
-            <a:ext cx="1097280" cy="239896"/>
+            <a:off x="4855464" y="3676964"/>
+            <a:ext cx="1097280" cy="261411"/>
           </a:xfrm>
           <a:prstGeom prst="rect">
             <a:avLst/>
@@ -8577,8 +8577,8 @@
         </p:nvSpPr>
         <p:spPr>
           <a:xfrm>
-            <a:off x="658368" y="3766252"/>
-            <a:ext cx="310896" cy="239896"/>
+            <a:off x="658368" y="3938375"/>
+            <a:ext cx="310896" cy="261411"/>
           </a:xfrm>
           <a:prstGeom prst="rect">
             <a:avLst/>
@@ -8616,8 +8616,8 @@
         </p:nvSpPr>
         <p:spPr>
           <a:xfrm>
-            <a:off x="1014984" y="3766252"/>
-            <a:ext cx="1920240" cy="239896"/>
+            <a:off x="1014984" y="3938375"/>
+            <a:ext cx="1920240" cy="261411"/>
           </a:xfrm>
           <a:prstGeom prst="rect">
             <a:avLst/>
@@ -8655,8 +8655,8 @@
         </p:nvSpPr>
         <p:spPr>
           <a:xfrm>
-            <a:off x="2980944" y="3831024"/>
-            <a:ext cx="424033" cy="110352"/>
+            <a:off x="2980944" y="4008956"/>
+            <a:ext cx="424033" cy="120249"/>
           </a:xfrm>
           <a:prstGeom prst="rect">
             <a:avLst/>
@@ -8675,8 +8675,8 @@
         </p:nvSpPr>
         <p:spPr>
           <a:xfrm>
-            <a:off x="4855464" y="3766252"/>
-            <a:ext cx="1097280" cy="239896"/>
+            <a:off x="4855464" y="3938375"/>
+            <a:ext cx="1097280" cy="261411"/>
           </a:xfrm>
           <a:prstGeom prst="rect">
             <a:avLst/>
@@ -8714,8 +8714,8 @@
         </p:nvSpPr>
         <p:spPr>
           <a:xfrm>
-            <a:off x="658368" y="4006148"/>
-            <a:ext cx="310896" cy="239896"/>
+            <a:off x="658368" y="4199785"/>
+            <a:ext cx="310896" cy="261411"/>
           </a:xfrm>
           <a:prstGeom prst="rect">
             <a:avLst/>
@@ -8753,8 +8753,8 @@
         </p:nvSpPr>
         <p:spPr>
           <a:xfrm>
-            <a:off x="1014984" y="4006148"/>
-            <a:ext cx="1920240" cy="239896"/>
+            <a:off x="1014984" y="4199785"/>
+            <a:ext cx="1920240" cy="261411"/>
           </a:xfrm>
           <a:prstGeom prst="rect">
             <a:avLst/>
@@ -8792,8 +8792,8 @@
         </p:nvSpPr>
         <p:spPr>
           <a:xfrm>
-            <a:off x="2980944" y="4070920"/>
-            <a:ext cx="421495" cy="110352"/>
+            <a:off x="2980944" y="4270366"/>
+            <a:ext cx="421495" cy="120249"/>
           </a:xfrm>
           <a:prstGeom prst="rect">
             <a:avLst/>
@@ -8812,8 +8812,8 @@
         </p:nvSpPr>
         <p:spPr>
           <a:xfrm>
-            <a:off x="4855464" y="4006148"/>
-            <a:ext cx="1097280" cy="239896"/>
+            <a:off x="4855464" y="4199785"/>
+            <a:ext cx="1097280" cy="261411"/>
           </a:xfrm>
           <a:prstGeom prst="rect">
             <a:avLst/>
@@ -8851,8 +8851,8 @@
         </p:nvSpPr>
         <p:spPr>
           <a:xfrm>
-            <a:off x="658368" y="4246043"/>
-            <a:ext cx="310896" cy="239896"/>
+            <a:off x="658368" y="4461196"/>
+            <a:ext cx="310896" cy="261411"/>
           </a:xfrm>
           <a:prstGeom prst="rect">
             <a:avLst/>
@@ -8890,8 +8890,8 @@
         </p:nvSpPr>
         <p:spPr>
           <a:xfrm>
-            <a:off x="1014984" y="4246043"/>
-            <a:ext cx="1920240" cy="239896"/>
+            <a:off x="1014984" y="4461196"/>
+            <a:ext cx="1920240" cy="261411"/>
           </a:xfrm>
           <a:prstGeom prst="rect">
             <a:avLst/>
@@ -8929,8 +8929,8 @@
         </p:nvSpPr>
         <p:spPr>
           <a:xfrm>
-            <a:off x="2980944" y="4310815"/>
-            <a:ext cx="310696" cy="110352"/>
+            <a:off x="2980944" y="4531777"/>
+            <a:ext cx="310696" cy="120249"/>
           </a:xfrm>
           <a:prstGeom prst="rect">
             <a:avLst/>
@@ -8949,8 +8949,8 @@
         </p:nvSpPr>
         <p:spPr>
           <a:xfrm>
-            <a:off x="4855464" y="4246043"/>
-            <a:ext cx="1097280" cy="239896"/>
+            <a:off x="4855464" y="4461196"/>
+            <a:ext cx="1097280" cy="261411"/>
           </a:xfrm>
           <a:prstGeom prst="rect">
             <a:avLst/>
@@ -8988,8 +8988,8 @@
         </p:nvSpPr>
         <p:spPr>
           <a:xfrm>
-            <a:off x="658368" y="4485939"/>
-            <a:ext cx="310896" cy="239896"/>
+            <a:off x="658368" y="4722607"/>
+            <a:ext cx="310896" cy="261411"/>
           </a:xfrm>
           <a:prstGeom prst="rect">
             <a:avLst/>
@@ -9027,8 +9027,8 @@
         </p:nvSpPr>
         <p:spPr>
           <a:xfrm>
-            <a:off x="1014984" y="4485939"/>
-            <a:ext cx="1920240" cy="239896"/>
+            <a:off x="1014984" y="4722607"/>
+            <a:ext cx="1920240" cy="261411"/>
           </a:xfrm>
           <a:prstGeom prst="rect">
             <a:avLst/>
@@ -9066,8 +9066,8 @@
         </p:nvSpPr>
         <p:spPr>
           <a:xfrm>
-            <a:off x="2980944" y="4550711"/>
-            <a:ext cx="308094" cy="110352"/>
+            <a:off x="2980944" y="4793188"/>
+            <a:ext cx="308094" cy="120249"/>
           </a:xfrm>
           <a:prstGeom prst="rect">
             <a:avLst/>
@@ -9086,8 +9086,8 @@
         </p:nvSpPr>
         <p:spPr>
           <a:xfrm>
-            <a:off x="4855464" y="4485939"/>
-            <a:ext cx="1097280" cy="239896"/>
+            <a:off x="4855464" y="4722607"/>
+            <a:ext cx="1097280" cy="261411"/>
           </a:xfrm>
           <a:prstGeom prst="rect">
             <a:avLst/>
@@ -9125,8 +9125,8 @@
         </p:nvSpPr>
         <p:spPr>
           <a:xfrm>
-            <a:off x="658368" y="4725834"/>
-            <a:ext cx="310896" cy="239896"/>
+            <a:off x="658368" y="4984018"/>
+            <a:ext cx="310896" cy="261411"/>
           </a:xfrm>
           <a:prstGeom prst="rect">
             <a:avLst/>
@@ -9164,8 +9164,8 @@
         </p:nvSpPr>
         <p:spPr>
           <a:xfrm>
-            <a:off x="1014984" y="4725834"/>
-            <a:ext cx="1920240" cy="239896"/>
+            <a:off x="1014984" y="4984018"/>
+            <a:ext cx="1920240" cy="261411"/>
           </a:xfrm>
           <a:prstGeom prst="rect">
             <a:avLst/>
@@ -9203,8 +9203,8 @@
         </p:nvSpPr>
         <p:spPr>
           <a:xfrm>
-            <a:off x="2980944" y="4790606"/>
-            <a:ext cx="279934" cy="110352"/>
+            <a:off x="2980944" y="5054599"/>
+            <a:ext cx="279934" cy="120249"/>
           </a:xfrm>
           <a:prstGeom prst="rect">
             <a:avLst/>
@@ -9223,8 +9223,8 @@
         </p:nvSpPr>
         <p:spPr>
           <a:xfrm>
-            <a:off x="4855464" y="4725834"/>
-            <a:ext cx="1097280" cy="239896"/>
+            <a:off x="4855464" y="4984018"/>
+            <a:ext cx="1097280" cy="261411"/>
           </a:xfrm>
           <a:prstGeom prst="rect">
             <a:avLst/>
@@ -9262,8 +9262,8 @@
         </p:nvSpPr>
         <p:spPr>
           <a:xfrm>
-            <a:off x="658368" y="4965730"/>
-            <a:ext cx="310896" cy="239896"/>
+            <a:off x="658368" y="5245429"/>
+            <a:ext cx="310896" cy="261411"/>
           </a:xfrm>
           <a:prstGeom prst="rect">
             <a:avLst/>
@@ -9301,8 +9301,8 @@
         </p:nvSpPr>
         <p:spPr>
           <a:xfrm>
-            <a:off x="1014984" y="4965730"/>
-            <a:ext cx="1920240" cy="239896"/>
+            <a:off x="1014984" y="5245429"/>
+            <a:ext cx="1920240" cy="261411"/>
           </a:xfrm>
           <a:prstGeom prst="rect">
             <a:avLst/>
@@ -9340,8 +9340,8 @@
         </p:nvSpPr>
         <p:spPr>
           <a:xfrm>
-            <a:off x="2980944" y="5030502"/>
-            <a:ext cx="273031" cy="110352"/>
+            <a:off x="2980944" y="5316010"/>
+            <a:ext cx="273031" cy="120249"/>
           </a:xfrm>
           <a:prstGeom prst="rect">
             <a:avLst/>
@@ -9360,8 +9360,8 @@
         </p:nvSpPr>
         <p:spPr>
           <a:xfrm>
-            <a:off x="4855464" y="4965730"/>
-            <a:ext cx="1097280" cy="239896"/>
+            <a:off x="4855464" y="5245429"/>
+            <a:ext cx="1097280" cy="261411"/>
           </a:xfrm>
           <a:prstGeom prst="rect">
             <a:avLst/>
@@ -9399,8 +9399,8 @@
         </p:nvSpPr>
         <p:spPr>
           <a:xfrm>
-            <a:off x="658368" y="5205625"/>
-            <a:ext cx="310896" cy="239896"/>
+            <a:off x="658368" y="5506840"/>
+            <a:ext cx="310896" cy="261411"/>
           </a:xfrm>
           <a:prstGeom prst="rect">
             <a:avLst/>
@@ -9438,8 +9438,8 @@
         </p:nvSpPr>
         <p:spPr>
           <a:xfrm>
-            <a:off x="1014984" y="5205625"/>
-            <a:ext cx="1920240" cy="239896"/>
+            <a:off x="1014984" y="5506840"/>
+            <a:ext cx="1920240" cy="261411"/>
           </a:xfrm>
           <a:prstGeom prst="rect">
             <a:avLst/>
@@ -9477,8 +9477,8 @@
         </p:nvSpPr>
         <p:spPr>
           <a:xfrm>
-            <a:off x="2980944" y="5270397"/>
-            <a:ext cx="272418" cy="110352"/>
+            <a:off x="2980944" y="5577420"/>
+            <a:ext cx="272418" cy="120249"/>
           </a:xfrm>
           <a:prstGeom prst="rect">
             <a:avLst/>
@@ -9497,8 +9497,8 @@
         </p:nvSpPr>
         <p:spPr>
           <a:xfrm>
-            <a:off x="4855464" y="5205625"/>
-            <a:ext cx="1097280" cy="239896"/>
+            <a:off x="4855464" y="5506840"/>
+            <a:ext cx="1097280" cy="261411"/>
           </a:xfrm>
           <a:prstGeom prst="rect">
             <a:avLst/>
@@ -9536,8 +9536,8 @@
         </p:nvSpPr>
         <p:spPr>
           <a:xfrm>
-            <a:off x="658368" y="5445521"/>
-            <a:ext cx="310896" cy="239896"/>
+            <a:off x="658368" y="5768250"/>
+            <a:ext cx="310896" cy="261411"/>
           </a:xfrm>
           <a:prstGeom prst="rect">
             <a:avLst/>
@@ -9575,8 +9575,8 @@
         </p:nvSpPr>
         <p:spPr>
           <a:xfrm>
-            <a:off x="1014984" y="5445521"/>
-            <a:ext cx="1920240" cy="239896"/>
+            <a:off x="1014984" y="5768250"/>
+            <a:ext cx="1920240" cy="261411"/>
           </a:xfrm>
           <a:prstGeom prst="rect">
             <a:avLst/>
@@ -9614,8 +9614,8 @@
         </p:nvSpPr>
         <p:spPr>
           <a:xfrm>
-            <a:off x="2980944" y="5510293"/>
-            <a:ext cx="261785" cy="110352"/>
+            <a:off x="2980944" y="5838831"/>
+            <a:ext cx="261785" cy="120249"/>
           </a:xfrm>
           <a:prstGeom prst="rect">
             <a:avLst/>
@@ -9634,8 +9634,8 @@
         </p:nvSpPr>
         <p:spPr>
           <a:xfrm>
-            <a:off x="4855464" y="5445521"/>
-            <a:ext cx="1097280" cy="239896"/>
+            <a:off x="4855464" y="5768250"/>
+            <a:ext cx="1097280" cy="261411"/>
           </a:xfrm>
           <a:prstGeom prst="rect">
             <a:avLst/>
@@ -9673,8 +9673,8 @@
         </p:nvSpPr>
         <p:spPr>
           <a:xfrm>
-            <a:off x="658368" y="5685416"/>
-            <a:ext cx="310896" cy="239896"/>
+            <a:off x="658368" y="6029661"/>
+            <a:ext cx="310896" cy="261411"/>
           </a:xfrm>
           <a:prstGeom prst="rect">
             <a:avLst/>
@@ -9712,8 +9712,8 @@
         </p:nvSpPr>
         <p:spPr>
           <a:xfrm>
-            <a:off x="1014984" y="5685416"/>
-            <a:ext cx="1920240" cy="239896"/>
+            <a:off x="1014984" y="6029661"/>
+            <a:ext cx="1920240" cy="261411"/>
           </a:xfrm>
           <a:prstGeom prst="rect">
             <a:avLst/>
@@ -9751,8 +9751,8 @@
         </p:nvSpPr>
         <p:spPr>
           <a:xfrm>
-            <a:off x="2980944" y="5750188"/>
-            <a:ext cx="254692" cy="110352"/>
+            <a:off x="2980944" y="6100242"/>
+            <a:ext cx="254692" cy="120249"/>
           </a:xfrm>
           <a:prstGeom prst="rect">
             <a:avLst/>
@@ -9771,8 +9771,8 @@
         </p:nvSpPr>
         <p:spPr>
           <a:xfrm>
-            <a:off x="4855464" y="5685416"/>
-            <a:ext cx="1097280" cy="239896"/>
+            <a:off x="4855464" y="6029661"/>
+            <a:ext cx="1097280" cy="261411"/>
           </a:xfrm>
           <a:prstGeom prst="rect">
             <a:avLst/>
@@ -9811,7 +9811,7 @@
         <p:spPr>
           <a:xfrm>
             <a:off x="6208776" y="1847088"/>
-            <a:ext cx="310896" cy="239896"/>
+            <a:ext cx="310896" cy="261411"/>
           </a:xfrm>
           <a:prstGeom prst="rect">
             <a:avLst/>
@@ -9850,7 +9850,7 @@
         <p:spPr>
           <a:xfrm>
             <a:off x="6565392" y="1847088"/>
-            <a:ext cx="1920240" cy="239896"/>
+            <a:ext cx="1920240" cy="261411"/>
           </a:xfrm>
           <a:prstGeom prst="rect">
             <a:avLst/>
@@ -9888,8 +9888,8 @@
         </p:nvSpPr>
         <p:spPr>
           <a:xfrm>
-            <a:off x="8531352" y="1911860"/>
-            <a:ext cx="230085" cy="110352"/>
+            <a:off x="8531352" y="1917669"/>
+            <a:ext cx="230085" cy="120249"/>
           </a:xfrm>
           <a:prstGeom prst="rect">
             <a:avLst/>
@@ -9909,7 +9909,7 @@
         <p:spPr>
           <a:xfrm>
             <a:off x="10405872" y="1847088"/>
-            <a:ext cx="1097280" cy="239896"/>
+            <a:ext cx="1097280" cy="261411"/>
           </a:xfrm>
           <a:prstGeom prst="rect">
             <a:avLst/>
@@ -9947,8 +9947,8 @@
         </p:nvSpPr>
         <p:spPr>
           <a:xfrm>
-            <a:off x="6208776" y="2086984"/>
-            <a:ext cx="310896" cy="239896"/>
+            <a:off x="6208776" y="2108499"/>
+            <a:ext cx="310896" cy="261411"/>
           </a:xfrm>
           <a:prstGeom prst="rect">
             <a:avLst/>
@@ -9986,8 +9986,8 @@
         </p:nvSpPr>
         <p:spPr>
           <a:xfrm>
-            <a:off x="6565392" y="2086984"/>
-            <a:ext cx="1920240" cy="239896"/>
+            <a:off x="6565392" y="2108499"/>
+            <a:ext cx="1920240" cy="261411"/>
           </a:xfrm>
           <a:prstGeom prst="rect">
             <a:avLst/>
@@ -10025,8 +10025,8 @@
         </p:nvSpPr>
         <p:spPr>
           <a:xfrm>
-            <a:off x="8531352" y="2151755"/>
-            <a:ext cx="210561" cy="110352"/>
+            <a:off x="8531352" y="2179080"/>
+            <a:ext cx="210561" cy="120249"/>
           </a:xfrm>
           <a:prstGeom prst="rect">
             <a:avLst/>
@@ -10045,8 +10045,8 @@
         </p:nvSpPr>
         <p:spPr>
           <a:xfrm>
-            <a:off x="10405872" y="2086984"/>
-            <a:ext cx="1097280" cy="239896"/>
+            <a:off x="10405872" y="2108499"/>
+            <a:ext cx="1097280" cy="261411"/>
           </a:xfrm>
           <a:prstGeom prst="rect">
             <a:avLst/>
@@ -10084,8 +10084,8 @@
         </p:nvSpPr>
         <p:spPr>
           <a:xfrm>
-            <a:off x="6208776" y="2326879"/>
-            <a:ext cx="310896" cy="239896"/>
+            <a:off x="6208776" y="2369910"/>
+            <a:ext cx="310896" cy="261411"/>
           </a:xfrm>
           <a:prstGeom prst="rect">
             <a:avLst/>
@@ -10123,8 +10123,8 @@
         </p:nvSpPr>
         <p:spPr>
           <a:xfrm>
-            <a:off x="6565392" y="2326879"/>
-            <a:ext cx="1920240" cy="239896"/>
+            <a:off x="6565392" y="2369910"/>
+            <a:ext cx="1920240" cy="261411"/>
           </a:xfrm>
           <a:prstGeom prst="rect">
             <a:avLst/>
@@ -10162,8 +10162,8 @@
         </p:nvSpPr>
         <p:spPr>
           <a:xfrm>
-            <a:off x="8531352" y="2391651"/>
-            <a:ext cx="186954" cy="110352"/>
+            <a:off x="8531352" y="2440491"/>
+            <a:ext cx="186954" cy="120249"/>
           </a:xfrm>
           <a:prstGeom prst="rect">
             <a:avLst/>
@@ -10182,8 +10182,8 @@
         </p:nvSpPr>
         <p:spPr>
           <a:xfrm>
-            <a:off x="10405872" y="2326879"/>
-            <a:ext cx="1097280" cy="239896"/>
+            <a:off x="10405872" y="2369910"/>
+            <a:ext cx="1097280" cy="261411"/>
           </a:xfrm>
           <a:prstGeom prst="rect">
             <a:avLst/>
@@ -10221,8 +10221,8 @@
         </p:nvSpPr>
         <p:spPr>
           <a:xfrm>
-            <a:off x="6208776" y="2566775"/>
-            <a:ext cx="310896" cy="239896"/>
+            <a:off x="6208776" y="2631320"/>
+            <a:ext cx="310896" cy="261411"/>
           </a:xfrm>
           <a:prstGeom prst="rect">
             <a:avLst/>
@@ -10260,8 +10260,8 @@
         </p:nvSpPr>
         <p:spPr>
           <a:xfrm>
-            <a:off x="6565392" y="2566775"/>
-            <a:ext cx="1920240" cy="239896"/>
+            <a:off x="6565392" y="2631320"/>
+            <a:ext cx="1920240" cy="261411"/>
           </a:xfrm>
           <a:prstGeom prst="rect">
             <a:avLst/>
@@ -10299,8 +10299,8 @@
         </p:nvSpPr>
         <p:spPr>
           <a:xfrm>
-            <a:off x="8531352" y="2631546"/>
-            <a:ext cx="164685" cy="110352"/>
+            <a:off x="8531352" y="2701901"/>
+            <a:ext cx="164685" cy="120249"/>
           </a:xfrm>
           <a:prstGeom prst="rect">
             <a:avLst/>
@@ -10319,8 +10319,8 @@
         </p:nvSpPr>
         <p:spPr>
           <a:xfrm>
-            <a:off x="10405872" y="2566775"/>
-            <a:ext cx="1097280" cy="239896"/>
+            <a:off x="10405872" y="2631320"/>
+            <a:ext cx="1097280" cy="261411"/>
           </a:xfrm>
           <a:prstGeom prst="rect">
             <a:avLst/>
@@ -10358,8 +10358,8 @@
         </p:nvSpPr>
         <p:spPr>
           <a:xfrm>
-            <a:off x="6208776" y="2806670"/>
-            <a:ext cx="310896" cy="239896"/>
+            <a:off x="6208776" y="2892731"/>
+            <a:ext cx="310896" cy="261411"/>
           </a:xfrm>
           <a:prstGeom prst="rect">
             <a:avLst/>
@@ -10397,8 +10397,8 @@
         </p:nvSpPr>
         <p:spPr>
           <a:xfrm>
-            <a:off x="6565392" y="2806670"/>
-            <a:ext cx="1920240" cy="239896"/>
+            <a:off x="6565392" y="2892731"/>
+            <a:ext cx="1920240" cy="261411"/>
           </a:xfrm>
           <a:prstGeom prst="rect">
             <a:avLst/>
@@ -10436,8 +10436,8 @@
         </p:nvSpPr>
         <p:spPr>
           <a:xfrm>
-            <a:off x="8531352" y="2871442"/>
-            <a:ext cx="163331" cy="110352"/>
+            <a:off x="8531352" y="2963312"/>
+            <a:ext cx="163331" cy="120249"/>
           </a:xfrm>
           <a:prstGeom prst="rect">
             <a:avLst/>
@@ -10456,8 +10456,8 @@
         </p:nvSpPr>
         <p:spPr>
           <a:xfrm>
-            <a:off x="10405872" y="2806670"/>
-            <a:ext cx="1097280" cy="239896"/>
+            <a:off x="10405872" y="2892731"/>
+            <a:ext cx="1097280" cy="261411"/>
           </a:xfrm>
           <a:prstGeom prst="rect">
             <a:avLst/>
@@ -10495,8 +10495,8 @@
         </p:nvSpPr>
         <p:spPr>
           <a:xfrm>
-            <a:off x="6208776" y="3046566"/>
-            <a:ext cx="310896" cy="239896"/>
+            <a:off x="6208776" y="3154142"/>
+            <a:ext cx="310896" cy="261411"/>
           </a:xfrm>
           <a:prstGeom prst="rect">
             <a:avLst/>
@@ -10534,8 +10534,8 @@
         </p:nvSpPr>
         <p:spPr>
           <a:xfrm>
-            <a:off x="6565392" y="3046566"/>
-            <a:ext cx="1920240" cy="239896"/>
+            <a:off x="6565392" y="3154142"/>
+            <a:ext cx="1920240" cy="261411"/>
           </a:xfrm>
           <a:prstGeom prst="rect">
             <a:avLst/>
@@ -10573,8 +10573,8 @@
         </p:nvSpPr>
         <p:spPr>
           <a:xfrm>
-            <a:off x="8531352" y="3111337"/>
-            <a:ext cx="158180" cy="110352"/>
+            <a:off x="8531352" y="3224723"/>
+            <a:ext cx="158180" cy="120249"/>
           </a:xfrm>
           <a:prstGeom prst="rect">
             <a:avLst/>
@@ -10593,8 +10593,8 @@
         </p:nvSpPr>
         <p:spPr>
           <a:xfrm>
-            <a:off x="10405872" y="3046566"/>
-            <a:ext cx="1097280" cy="239896"/>
+            <a:off x="10405872" y="3154142"/>
+            <a:ext cx="1097280" cy="261411"/>
           </a:xfrm>
           <a:prstGeom prst="rect">
             <a:avLst/>
@@ -10632,8 +10632,8 @@
         </p:nvSpPr>
         <p:spPr>
           <a:xfrm>
-            <a:off x="6208776" y="3286461"/>
-            <a:ext cx="310896" cy="239896"/>
+            <a:off x="6208776" y="3415553"/>
+            <a:ext cx="310896" cy="261411"/>
           </a:xfrm>
           <a:prstGeom prst="rect">
             <a:avLst/>
@@ -10671,8 +10671,8 @@
         </p:nvSpPr>
         <p:spPr>
           <a:xfrm>
-            <a:off x="6565392" y="3286461"/>
-            <a:ext cx="1920240" cy="239896"/>
+            <a:off x="6565392" y="3415553"/>
+            <a:ext cx="1920240" cy="261411"/>
           </a:xfrm>
           <a:prstGeom prst="rect">
             <a:avLst/>
@@ -10710,8 +10710,8 @@
         </p:nvSpPr>
         <p:spPr>
           <a:xfrm>
-            <a:off x="8531352" y="3351233"/>
-            <a:ext cx="117270" cy="110352"/>
+            <a:off x="8531352" y="3486134"/>
+            <a:ext cx="117270" cy="120249"/>
           </a:xfrm>
           <a:prstGeom prst="rect">
             <a:avLst/>
@@ -10730,8 +10730,8 @@
         </p:nvSpPr>
         <p:spPr>
           <a:xfrm>
-            <a:off x="10405872" y="3286461"/>
-            <a:ext cx="1097280" cy="239896"/>
+            <a:off x="10405872" y="3415553"/>
+            <a:ext cx="1097280" cy="261411"/>
           </a:xfrm>
           <a:prstGeom prst="rect">
             <a:avLst/>
@@ -10769,8 +10769,8 @@
         </p:nvSpPr>
         <p:spPr>
           <a:xfrm>
-            <a:off x="6208776" y="3526357"/>
-            <a:ext cx="310896" cy="239896"/>
+            <a:off x="6208776" y="3676964"/>
+            <a:ext cx="310896" cy="261411"/>
           </a:xfrm>
           <a:prstGeom prst="rect">
             <a:avLst/>
@@ -10808,8 +10808,8 @@
         </p:nvSpPr>
         <p:spPr>
           <a:xfrm>
-            <a:off x="6565392" y="3526357"/>
-            <a:ext cx="1920240" cy="239896"/>
+            <a:off x="6565392" y="3676964"/>
+            <a:ext cx="1920240" cy="261411"/>
           </a:xfrm>
           <a:prstGeom prst="rect">
             <a:avLst/>
@@ -10847,8 +10847,8 @@
         </p:nvSpPr>
         <p:spPr>
           <a:xfrm>
-            <a:off x="8531352" y="3591128"/>
-            <a:ext cx="111208" cy="110352"/>
+            <a:off x="8531352" y="3747545"/>
+            <a:ext cx="111208" cy="120249"/>
           </a:xfrm>
           <a:prstGeom prst="rect">
             <a:avLst/>
@@ -10867,8 +10867,8 @@
         </p:nvSpPr>
         <p:spPr>
           <a:xfrm>
-            <a:off x="10405872" y="3526357"/>
-            <a:ext cx="1097280" cy="239896"/>
+            <a:off x="10405872" y="3676964"/>
+            <a:ext cx="1097280" cy="261411"/>
           </a:xfrm>
           <a:prstGeom prst="rect">
             <a:avLst/>
@@ -10906,8 +10906,8 @@
         </p:nvSpPr>
         <p:spPr>
           <a:xfrm>
-            <a:off x="6208776" y="3766252"/>
-            <a:ext cx="310896" cy="239896"/>
+            <a:off x="6208776" y="3938375"/>
+            <a:ext cx="310896" cy="261411"/>
           </a:xfrm>
           <a:prstGeom prst="rect">
             <a:avLst/>
@@ -10945,8 +10945,8 @@
         </p:nvSpPr>
         <p:spPr>
           <a:xfrm>
-            <a:off x="6565392" y="3766252"/>
-            <a:ext cx="1920240" cy="239896"/>
+            <a:off x="6565392" y="3938375"/>
+            <a:ext cx="1920240" cy="261411"/>
           </a:xfrm>
           <a:prstGeom prst="rect">
             <a:avLst/>
@@ -10984,8 +10984,8 @@
         </p:nvSpPr>
         <p:spPr>
           <a:xfrm>
-            <a:off x="8531352" y="3831024"/>
-            <a:ext cx="99951" cy="110352"/>
+            <a:off x="8531352" y="4008956"/>
+            <a:ext cx="99951" cy="120249"/>
           </a:xfrm>
           <a:prstGeom prst="rect">
             <a:avLst/>
@@ -11004,8 +11004,8 @@
         </p:nvSpPr>
         <p:spPr>
           <a:xfrm>
-            <a:off x="10405872" y="3766252"/>
-            <a:ext cx="1097280" cy="239896"/>
+            <a:off x="10405872" y="3938375"/>
+            <a:ext cx="1097280" cy="261411"/>
           </a:xfrm>
           <a:prstGeom prst="rect">
             <a:avLst/>
@@ -11043,8 +11043,8 @@
         </p:nvSpPr>
         <p:spPr>
           <a:xfrm>
-            <a:off x="6208776" y="4006148"/>
-            <a:ext cx="310896" cy="239896"/>
+            <a:off x="6208776" y="4199785"/>
+            <a:ext cx="310896" cy="261411"/>
           </a:xfrm>
           <a:prstGeom prst="rect">
             <a:avLst/>
@@ -11082,8 +11082,8 @@
         </p:nvSpPr>
         <p:spPr>
           <a:xfrm>
-            <a:off x="6565392" y="4006148"/>
-            <a:ext cx="1920240" cy="239896"/>
+            <a:off x="6565392" y="4199785"/>
+            <a:ext cx="1920240" cy="261411"/>
           </a:xfrm>
           <a:prstGeom prst="rect">
             <a:avLst/>
@@ -11121,8 +11121,8 @@
         </p:nvSpPr>
         <p:spPr>
           <a:xfrm>
-            <a:off x="8531352" y="4070920"/>
-            <a:ext cx="30021" cy="110352"/>
+            <a:off x="8531352" y="4270366"/>
+            <a:ext cx="30021" cy="120249"/>
           </a:xfrm>
           <a:prstGeom prst="rect">
             <a:avLst/>
@@ -11141,8 +11141,8 @@
         </p:nvSpPr>
         <p:spPr>
           <a:xfrm>
-            <a:off x="10405872" y="4006148"/>
-            <a:ext cx="1097280" cy="239896"/>
+            <a:off x="10405872" y="4199785"/>
+            <a:ext cx="1097280" cy="261411"/>
           </a:xfrm>
           <a:prstGeom prst="rect">
             <a:avLst/>
@@ -11180,8 +11180,8 @@
         </p:nvSpPr>
         <p:spPr>
           <a:xfrm>
-            <a:off x="6208776" y="4246043"/>
-            <a:ext cx="310896" cy="239896"/>
+            <a:off x="6208776" y="4461196"/>
+            <a:ext cx="310896" cy="261411"/>
           </a:xfrm>
           <a:prstGeom prst="rect">
             <a:avLst/>
@@ -11219,8 +11219,8 @@
         </p:nvSpPr>
         <p:spPr>
           <a:xfrm>
-            <a:off x="6565392" y="4246043"/>
-            <a:ext cx="1920240" cy="239896"/>
+            <a:off x="6565392" y="4461196"/>
+            <a:ext cx="1920240" cy="261411"/>
           </a:xfrm>
           <a:prstGeom prst="rect">
             <a:avLst/>
@@ -11258,8 +11258,8 @@
         </p:nvSpPr>
         <p:spPr>
           <a:xfrm>
-            <a:off x="8531352" y="4310815"/>
-            <a:ext cx="25197" cy="110352"/>
+            <a:off x="8531352" y="4531777"/>
+            <a:ext cx="25197" cy="120249"/>
           </a:xfrm>
           <a:prstGeom prst="rect">
             <a:avLst/>
@@ -11278,8 +11278,8 @@
         </p:nvSpPr>
         <p:spPr>
           <a:xfrm>
-            <a:off x="10405872" y="4246043"/>
-            <a:ext cx="1097280" cy="239896"/>
+            <a:off x="10405872" y="4461196"/>
+            <a:ext cx="1097280" cy="261411"/>
           </a:xfrm>
           <a:prstGeom prst="rect">
             <a:avLst/>
@@ -11317,8 +11317,8 @@
         </p:nvSpPr>
         <p:spPr>
           <a:xfrm>
-            <a:off x="6208776" y="4485939"/>
-            <a:ext cx="310896" cy="239896"/>
+            <a:off x="6208776" y="4722607"/>
+            <a:ext cx="310896" cy="261411"/>
           </a:xfrm>
           <a:prstGeom prst="rect">
             <a:avLst/>
@@ -11356,8 +11356,8 @@
         </p:nvSpPr>
         <p:spPr>
           <a:xfrm>
-            <a:off x="6565392" y="4485939"/>
-            <a:ext cx="1920240" cy="239896"/>
+            <a:off x="6565392" y="4722607"/>
+            <a:ext cx="1920240" cy="261411"/>
           </a:xfrm>
           <a:prstGeom prst="rect">
             <a:avLst/>
@@ -11395,8 +11395,8 @@
         </p:nvSpPr>
         <p:spPr>
           <a:xfrm>
-            <a:off x="8531352" y="4550711"/>
-            <a:ext cx="22055" cy="110352"/>
+            <a:off x="8531352" y="4793188"/>
+            <a:ext cx="22055" cy="120249"/>
           </a:xfrm>
           <a:prstGeom prst="rect">
             <a:avLst/>
@@ -11415,8 +11415,8 @@
         </p:nvSpPr>
         <p:spPr>
           <a:xfrm>
-            <a:off x="10405872" y="4485939"/>
-            <a:ext cx="1097280" cy="239896"/>
+            <a:off x="10405872" y="4722607"/>
+            <a:ext cx="1097280" cy="261411"/>
           </a:xfrm>
           <a:prstGeom prst="rect">
             <a:avLst/>
@@ -11454,8 +11454,8 @@
         </p:nvSpPr>
         <p:spPr>
           <a:xfrm>
-            <a:off x="6208776" y="4725834"/>
-            <a:ext cx="310896" cy="239896"/>
+            <a:off x="6208776" y="4984018"/>
+            <a:ext cx="310896" cy="261411"/>
           </a:xfrm>
           <a:prstGeom prst="rect">
             <a:avLst/>
@@ -11493,8 +11493,8 @@
         </p:nvSpPr>
         <p:spPr>
           <a:xfrm>
-            <a:off x="6565392" y="4725834"/>
-            <a:ext cx="1920240" cy="239896"/>
+            <a:off x="6565392" y="4984018"/>
+            <a:ext cx="1920240" cy="261411"/>
           </a:xfrm>
           <a:prstGeom prst="rect">
             <a:avLst/>
@@ -11532,8 +11532,8 @@
         </p:nvSpPr>
         <p:spPr>
           <a:xfrm>
-            <a:off x="8531352" y="4790606"/>
-            <a:ext cx="18567" cy="110352"/>
+            <a:off x="8531352" y="5054599"/>
+            <a:ext cx="18567" cy="120249"/>
           </a:xfrm>
           <a:prstGeom prst="rect">
             <a:avLst/>
@@ -11552,8 +11552,8 @@
         </p:nvSpPr>
         <p:spPr>
           <a:xfrm>
-            <a:off x="10405872" y="4725834"/>
-            <a:ext cx="1097280" cy="239896"/>
+            <a:off x="10405872" y="4984018"/>
+            <a:ext cx="1097280" cy="261411"/>
           </a:xfrm>
           <a:prstGeom prst="rect">
             <a:avLst/>
@@ -11591,8 +11591,8 @@
         </p:nvSpPr>
         <p:spPr>
           <a:xfrm>
-            <a:off x="6208776" y="4965730"/>
-            <a:ext cx="310896" cy="239896"/>
+            <a:off x="6208776" y="5245429"/>
+            <a:ext cx="310896" cy="261411"/>
           </a:xfrm>
           <a:prstGeom prst="rect">
             <a:avLst/>
@@ -11630,8 +11630,8 @@
         </p:nvSpPr>
         <p:spPr>
           <a:xfrm>
-            <a:off x="6565392" y="4965730"/>
-            <a:ext cx="1920240" cy="239896"/>
+            <a:off x="6565392" y="5245429"/>
+            <a:ext cx="1920240" cy="261411"/>
           </a:xfrm>
           <a:prstGeom prst="rect">
             <a:avLst/>
@@ -11669,8 +11669,8 @@
         </p:nvSpPr>
         <p:spPr>
           <a:xfrm>
-            <a:off x="8531352" y="5030502"/>
-            <a:ext cx="18288" cy="110352"/>
+            <a:off x="8531352" y="5316010"/>
+            <a:ext cx="18288" cy="120249"/>
           </a:xfrm>
           <a:prstGeom prst="rect">
             <a:avLst/>
@@ -11689,8 +11689,8 @@
         </p:nvSpPr>
         <p:spPr>
           <a:xfrm>
-            <a:off x="10405872" y="4965730"/>
-            <a:ext cx="1097280" cy="239896"/>
+            <a:off x="10405872" y="5245429"/>
+            <a:ext cx="1097280" cy="261411"/>
           </a:xfrm>
           <a:prstGeom prst="rect">
             <a:avLst/>
@@ -11728,8 +11728,8 @@
         </p:nvSpPr>
         <p:spPr>
           <a:xfrm>
-            <a:off x="6208776" y="5205625"/>
-            <a:ext cx="310896" cy="239896"/>
+            <a:off x="6208776" y="5506840"/>
+            <a:ext cx="310896" cy="261411"/>
           </a:xfrm>
           <a:prstGeom prst="rect">
             <a:avLst/>
@@ -11767,8 +11767,8 @@
         </p:nvSpPr>
         <p:spPr>
           <a:xfrm>
-            <a:off x="6565392" y="5205625"/>
-            <a:ext cx="1920240" cy="239896"/>
+            <a:off x="6565392" y="5506840"/>
+            <a:ext cx="1920240" cy="261411"/>
           </a:xfrm>
           <a:prstGeom prst="rect">
             <a:avLst/>
@@ -11806,8 +11806,8 @@
         </p:nvSpPr>
         <p:spPr>
           <a:xfrm>
-            <a:off x="8531352" y="5270397"/>
-            <a:ext cx="18288" cy="110352"/>
+            <a:off x="8531352" y="5577420"/>
+            <a:ext cx="18288" cy="120249"/>
           </a:xfrm>
           <a:prstGeom prst="rect">
             <a:avLst/>
@@ -11826,8 +11826,8 @@
         </p:nvSpPr>
         <p:spPr>
           <a:xfrm>
-            <a:off x="10405872" y="5205625"/>
-            <a:ext cx="1097280" cy="239896"/>
+            <a:off x="10405872" y="5506840"/>
+            <a:ext cx="1097280" cy="261411"/>
           </a:xfrm>
           <a:prstGeom prst="rect">
             <a:avLst/>
@@ -11865,8 +11865,8 @@
         </p:nvSpPr>
         <p:spPr>
           <a:xfrm>
-            <a:off x="6208776" y="5445521"/>
-            <a:ext cx="310896" cy="239896"/>
+            <a:off x="6208776" y="5768250"/>
+            <a:ext cx="310896" cy="261411"/>
           </a:xfrm>
           <a:prstGeom prst="rect">
             <a:avLst/>
@@ -11904,8 +11904,8 @@
         </p:nvSpPr>
         <p:spPr>
           <a:xfrm>
-            <a:off x="6565392" y="5445521"/>
-            <a:ext cx="1920240" cy="239896"/>
+            <a:off x="6565392" y="5768250"/>
+            <a:ext cx="1920240" cy="261411"/>
           </a:xfrm>
           <a:prstGeom prst="rect">
             <a:avLst/>
@@ -11943,8 +11943,8 @@
         </p:nvSpPr>
         <p:spPr>
           <a:xfrm>
-            <a:off x="8531352" y="5510293"/>
-            <a:ext cx="31883" cy="110352"/>
+            <a:off x="8531352" y="5838831"/>
+            <a:ext cx="31883" cy="120249"/>
           </a:xfrm>
           <a:prstGeom prst="rect">
             <a:avLst/>
@@ -11963,8 +11963,8 @@
         </p:nvSpPr>
         <p:spPr>
           <a:xfrm>
-            <a:off x="10405872" y="5445521"/>
-            <a:ext cx="1097280" cy="239896"/>
+            <a:off x="10405872" y="5768250"/>
+            <a:ext cx="1097280" cy="261411"/>
           </a:xfrm>
           <a:prstGeom prst="rect">
             <a:avLst/>
@@ -12003,7 +12003,7 @@
         <p:spPr>
           <a:xfrm>
             <a:off x="6085332" y="1847088"/>
-            <a:ext cx="10973" cy="4078224"/>
+            <a:ext cx="10973" cy="4443984"/>
           </a:xfrm>
           <a:prstGeom prst="rect">
             <a:avLst/>
@@ -12013,65 +12013,6 @@
           </a:solidFill>
           <a:ln/>
         </p:spPr>
-      </p:sp>
-      <p:sp>
-        <p:nvSpPr>
-          <p:cNvPr id="145" name="Shape 142"/>
-          <p:cNvSpPr/>
-          <p:nvPr/>
-        </p:nvSpPr>
-        <p:spPr>
-          <a:xfrm>
-            <a:off x="457200" y="6126480"/>
-            <a:ext cx="11274552" cy="371856"/>
-          </a:xfrm>
-          <a:prstGeom prst="rect">
-            <a:avLst/>
-          </a:prstGeom>
-          <a:solidFill>
-            <a:srgbClr val="EDF4FA"/>
-          </a:solidFill>
-          <a:ln/>
-        </p:spPr>
-      </p:sp>
-      <p:sp>
-        <p:nvSpPr>
-          <p:cNvPr id="146" name="Text 143"/>
-          <p:cNvSpPr txBox="1"/>
-          <p:nvPr/>
-        </p:nvSpPr>
-        <p:spPr>
-          <a:xfrm>
-            <a:off x="658368" y="6144768"/>
-            <a:ext cx="10927080" cy="335280"/>
-          </a:xfrm>
-          <a:prstGeom prst="rect">
-            <a:avLst/>
-          </a:prstGeom>
-          <a:noFill/>
-          <a:ln/>
-        </p:spPr>
-        <p:txBody>
-          <a:bodyPr wrap="square" lIns="0" tIns="0" rIns="0" bIns="0" rtlCol="0" anchor="ctr"/>
-          <a:lstStyle/>
-          <a:p>
-            <a:pPr indent="0" marL="0">
-              <a:buNone/>
-            </a:pPr>
-            <a:r>
-              <a:rPr lang="en-US" sz="1600" b="1" dirty="0">
-                <a:solidFill>
-                  <a:srgbClr val="0B2C4A"/>
-                </a:solidFill>
-                <a:latin typeface="Inter" pitchFamily="34" charset="0"/>
-                <a:ea typeface="Inter" pitchFamily="34" charset="-122"/>
-                <a:cs typeface="Inter" pitchFamily="34" charset="-120"/>
-              </a:rPr>
-              <a:t>2 stores are losing money in fixed ops.</a:t>
-            </a:r>
-            <a:endParaRPr lang="en-US" sz="1600" dirty="0"/>
-          </a:p>
-        </p:txBody>
       </p:sp>
     </p:spTree>
   </p:cSld>
@@ -18657,7 +18598,7 @@
                 <a:ea typeface="Inter" pitchFamily="34" charset="-122"/>
                 <a:cs typeface="Inter" pitchFamily="34" charset="-120"/>
               </a:rPr>
-              <a:t>24 of 33 stores grew.</a:t>
+              <a:t>24 of 33 stores grew fixed ops net profit, January through September year to date.</a:t>
             </a:r>
             <a:endParaRPr lang="en-US" sz="1600" dirty="0"/>
           </a:p>

</xml_diff>

<commit_message>
Day 2 deck: data audit fixes - proficiency band, 0.1 hr at $6.6M a year, one rule for changes, GMC Prescott body shop out of absorption
Co-Authored-By: Claude Opus 5.5 <noreply@anthropic.com>
Claude-Session: https://claude.ai/code/session_01Xa4nFVxuQGXmHARGph9WhS
</commit_message>
<xml_diff>
--- a/day2-deck/decks/Fixed Absorption & Net Profit - House Style.pptx
+++ b/day2-deck/decks/Fixed Absorption & Net Profit - House Style.pptx
@@ -2377,7 +2377,7 @@
           <a:p>
             <a:r>
               <a:rPr lang="en-US" dirty="0"/>
-              <a:t>Source: Qlik - Profit &amp; Loss, GM statement. Jan-Sep 2026, same-store, INEOS excluded (opened 2026).PLACE: Profitability, in front of Fixed Ops Absorption %; the next slide breaks down the fixed expenses. The denominator is the P&amp;L's Fixed Expenses line on the GM statement: the whole store's expenses (new, used, service, parts, body shop) less the costs that move with each car sold: sales and F&amp;I commissions, delivery, policy, floorplan interest, and new and used vehicle advertising. That matches the standard dealer definition: fixed ops gross divided by total store overhead, excluding the variable costs of selling cars. Jan-Sep 2026 same-store: $242,850,782 of fixed expenses out of $305,051,366 total expense.</a:t>
+              <a:t>Source: Qlik - Profit &amp; Loss, GM statement. Jan-Sep 2026, same-store, INEOS excluded (opened 2026).PLACE: Profitability, in front of Fixed Ops Absorption %; the next slide breaks down the fixed expenses. The denominator is the P&amp;L's Fixed Expenses line on the GM statement: the whole store's expenses (new, used, service and parts; the GMC Prescott body shop is taken out, as everywhere in the deck) less the costs that move with each car sold: sales and F&amp;I commissions, delivery, policy, floorplan interest, and new and used vehicle advertising. That matches the standard dealer definition: fixed ops gross divided by total store overhead, excluding the variable costs of selling cars. Jan-Sep 2026 same-store: $242,385,781 of fixed expenses out of $304,576,351 total expense.</a:t>
             </a:r>
             <a:endParaRPr lang="en-US" dirty="0"/>
           </a:p>
@@ -2465,7 +2465,7 @@
           <a:p>
             <a:r>
               <a:rPr lang="en-US" dirty="0"/>
-              <a:t>Source: Qlik - Profit &amp; Loss, GM statement. Jan-Sep 2026, same-store, INEOS excluded (opened 2026). Fixed Expenses line by account class, every department of the store; categories reconcile to the line to the cent ($242,850,782).</a:t>
+              <a:t>Source: Qlik - Profit &amp; Loss, GM statement. Jan-Sep 2026, same-store, INEOS excluded (opened 2026). Fixed Expenses line by account class, every department of the store; categories reconcile to the line to the cent ($242,385,781).</a:t>
             </a:r>
             <a:endParaRPr lang="en-US" dirty="0"/>
           </a:p>
@@ -3725,7 +3725,7 @@
                 <a:ea typeface="Inter" pitchFamily="34" charset="-122"/>
                 <a:cs typeface="Inter" pitchFamily="34" charset="-120"/>
               </a:rPr>
-              <a:t>78.1%</a:t>
+              <a:t>77.9%</a:t>
             </a:r>
             <a:endParaRPr lang="en-US" sz="1400" dirty="0"/>
           </a:p>
@@ -4291,7 +4291,7 @@
                 <a:ea typeface="Inter" pitchFamily="34" charset="-122"/>
                 <a:cs typeface="Inter" pitchFamily="34" charset="-120"/>
               </a:rPr>
-              <a:t>Group: 78.1% absorption, up 2.1 pts. Fixed gross grew 4.1%; fixed expenses 1.3%.</a:t>
+              <a:t>Group: 77.9% absorption, up 2.1 pts. Fixed gross grew 4.1%; fixed expenses 1.4%.</a:t>
             </a:r>
             <a:endParaRPr lang="en-US" sz="1600" dirty="0"/>
           </a:p>
@@ -4561,7 +4561,7 @@
                 <a:ea typeface="Inter" pitchFamily="34" charset="-122"/>
                 <a:cs typeface="Inter" pitchFamily="34" charset="-120"/>
               </a:rPr>
-              <a:t>$147.9M</a:t>
+              <a:t>$147.7M</a:t>
             </a:r>
             <a:endParaRPr lang="en-US" sz="3600" dirty="0"/>
           </a:p>
@@ -4720,7 +4720,7 @@
                 <a:ea typeface="Inter" pitchFamily="34" charset="-122"/>
                 <a:cs typeface="Inter" pitchFamily="34" charset="-120"/>
               </a:rPr>
-              <a:t>$39.1M</a:t>
+              <a:t>$39.0M</a:t>
             </a:r>
             <a:endParaRPr lang="en-US" sz="3600" dirty="0"/>
           </a:p>
@@ -4879,7 +4879,7 @@
                 <a:ea typeface="Inter" pitchFamily="34" charset="-122"/>
                 <a:cs typeface="Inter" pitchFamily="34" charset="-120"/>
               </a:rPr>
-              <a:t>$36.4M</a:t>
+              <a:t>$36.3M</a:t>
             </a:r>
             <a:endParaRPr lang="en-US" sz="3600" dirty="0"/>
           </a:p>
@@ -5038,7 +5038,7 @@
                 <a:ea typeface="Inter" pitchFamily="34" charset="-122"/>
                 <a:cs typeface="Inter" pitchFamily="34" charset="-120"/>
               </a:rPr>
-              <a:t>$19.5M</a:t>
+              <a:t>$19.4M</a:t>
             </a:r>
             <a:endParaRPr lang="en-US" sz="3600" dirty="0"/>
           </a:p>
@@ -5175,7 +5175,7 @@
                 <a:ea typeface="Inter" pitchFamily="34" charset="-122"/>
                 <a:cs typeface="Inter" pitchFamily="34" charset="-120"/>
               </a:rPr>
-              <a:t>$242.9M of fixed expenses Jan-Sep 2026; fixed ops gross of $189.7M covers 78.1% of it. People are 61% of the total.</a:t>
+              <a:t>$242.4M of fixed expenses Jan-Sep 2026; fixed ops gross of $188.8M covers 77.9% of it. People are 61% of the total.</a:t>
             </a:r>
             <a:endParaRPr lang="en-US" sz="1600" dirty="0"/>
           </a:p>

</xml_diff>

<commit_message>
Day 2 deck: audit proposals (wording, Flai dates and callback list, slide 143 band, Two Ways tie, What Changed opcode row, notes); section dividers review file
Co-Authored-By: Claude Opus 5.5 <noreply@anthropic.com>
Claude-Session: https://claude.ai/code/session_01Xa4nFVxuQGXmHARGph9WhS
</commit_message>
<xml_diff>
--- a/day2-deck/decks/Fixed Absorption & Net Profit - House Style.pptx
+++ b/day2-deck/decks/Fixed Absorption & Net Profit - House Style.pptx
@@ -2377,7 +2377,7 @@
           <a:p>
             <a:r>
               <a:rPr lang="en-US" dirty="0"/>
-              <a:t>Source: Qlik - Profit &amp; Loss, GM statement. Jan-Sep 2026, same-store, INEOS excluded (opened 2026).PLACE: Profitability, in front of Fixed Ops Absorption %; the next slide breaks down the fixed expenses. The denominator is the P&amp;L's Fixed Expenses line on the GM statement: the whole store's expenses (new, used, service and parts; the GMC Prescott body shop is taken out, as everywhere in the deck) less the costs that move with each car sold: sales and F&amp;I commissions, delivery, policy, floorplan interest, and new and used vehicle advertising. That matches the standard dealer definition: fixed ops gross divided by total store overhead, excluding the variable costs of selling cars. Jan-Sep 2026 same-store: $242,385,781 of fixed expenses out of $304,576,351 total expense.</a:t>
+              <a:t>Source: Qlik - Profit &amp; Loss, GM statement. Jan-Sep 2026, same-store, INEOS excluded (opened 2026).PLACE: Profitability, in front of Fixed Ops Absorption % (the next slide, the trend). The breakdown of total store fixed expenses is on this slide. The denominator is the P&amp;L's Fixed Expenses line on the GM statement: the whole store's expenses (new, used, service and parts; the GMC Prescott body shop is taken out, as everywhere in the deck) less the costs that move with each car sold: sales and F&amp;I commissions, delivery, policy, floorplan interest, and new and used vehicle advertising. That matches the standard dealer definition: fixed ops gross divided by total store overhead, excluding the variable costs of selling cars. Jan-Sep 2026 same-store: $242,385,781 of fixed expenses out of $304,576,351 total expense.</a:t>
             </a:r>
             <a:endParaRPr lang="en-US" dirty="0"/>
           </a:p>
@@ -2905,7 +2905,7 @@
           <a:p>
             <a:r>
               <a:rPr lang="en-US" dirty="0"/>
-              <a:t>Takeaway with the store call-outs (off the slide): Ask Toyota Henderson, Audi Henderson and Cadillac what changed. Ask Chevy LV, VW Henderson and Toyota Spokane what got in the way. Ask Honda Henderson, Toyota Henderson and Chevy LV what they started this year.Source: Qlik - Profit &amp; Loss, Detail statement. Same-store, INEOS excluded (opened 2026). Fixed ops net profit = service (Mechanical) + parts (P&amp;A) department profit: department gross less the department's own expenses; GMC Prescott body shop is its own department and is not included. Top and bottom five stores by dollar change in fixed ops net profit, Jan-Sep 2026 vs 2025 (dollars, not percent: several stores lost money in 2025). Moving now: Jul-Sep 2026 vs Jan-Mar 2026, each store against itself (monthly averages); the group moved +$1.05M a month on the same basis, so part of every store's change is seasonal. Green bar at the right of a row: the store is on both the top five vs last year and the top five moving now.Conversation starter: each top store says one thing they started doing; each bottom store says what got in the way and what they would try. The room trades ideas. Moving now: ask the top three what they started this year.</a:t>
+              <a:t>Takeaway with the store call-outs (off the slide): Ask Toyota Henderson, Audi Henderson and Cadillac what changed. Ask Chevy LV, VW Henderson and Toyota Spokane what got in the way. Ask Honda Henderson, Toyota Henderson and Chevy LV what they started this year.Source: Qlik - Profit &amp; Loss, Detail statement. Same-store, INEOS excluded (opened 2026). Fixed ops net profit = service (Mechanical) + parts (P&amp;A) department profit: department gross less the department's own expenses; GMC Prescott body shop is its own department and is not included. Top and bottom five stores by dollar change in fixed ops net profit, Jan-Sep 2026 vs 2025 (dollars, not percent: several stores lost money in 2025). Moving now: Jul-Sep 2026 vs Jan-Mar 2026, each store against itself (monthly averages); the group moved +$1.05M a month on the same basis, so part of every store's change is seasonal. Green bar at the right of a row: the store is on both the top five vs last year and the top five moving now. Blue bar: a turnaround, on the bottom five vs last year and the top five moving now.Conversation starter: each top store says one thing they started doing; each bottom store says what got in the way and what they would try. The room trades ideas. Moving now: ask the top three what they started this year.</a:t>
             </a:r>
             <a:endParaRPr lang="en-US" dirty="0"/>
           </a:p>
@@ -7160,7 +7160,7 @@
                 <a:ea typeface="Inter" pitchFamily="34" charset="-122"/>
                 <a:cs typeface="Inter" pitchFamily="34" charset="-120"/>
               </a:rPr>
-              <a:t>+$5.11M (+11.3%) year to date; 7 of nine months ahead of 2025, best September at +$1.61M.</a:t>
+              <a:t>+$5.11M (+11.3%) year to date; 7 of nine months ahead of 2025, largest gain in September, +$1.61M.</a:t>
             </a:r>
             <a:endParaRPr lang="en-US" sz="1600" dirty="0"/>
           </a:p>

</xml_diff>

<commit_message>
Day 2 deck: Biggest Movers This Year split; gray second line on RO count, gross and net profit movers
Co-Authored-By: Claude Opus 5.5 <noreply@anthropic.com>
Claude-Session: https://claude.ai/code/session_01Xa4nFVxuQGXmHARGph9WhS
</commit_message>
<xml_diff>
--- a/day2-deck/decks/Fixed Absorption & Net Profit - House Style.pptx
+++ b/day2-deck/decks/Fixed Absorption & Net Profit - House Style.pptx
@@ -19018,17 +19018,17 @@
         </p:nvSpPr>
         <p:spPr>
           <a:xfrm>
-            <a:off x="2941320" y="2103120"/>
-            <a:ext cx="1115568" cy="828446"/>
-          </a:xfrm>
-          <a:prstGeom prst="rect">
-            <a:avLst/>
-          </a:prstGeom>
-          <a:noFill/>
-          <a:ln/>
-        </p:spPr>
-        <p:txBody>
-          <a:bodyPr wrap="square" lIns="0" tIns="0" rIns="0" bIns="0" rtlCol="0" anchor="ctr"/>
+            <a:off x="2941320" y="2202534"/>
+            <a:ext cx="1115568" cy="414223"/>
+          </a:xfrm>
+          <a:prstGeom prst="rect">
+            <a:avLst/>
+          </a:prstGeom>
+          <a:noFill/>
+          <a:ln/>
+        </p:spPr>
+        <p:txBody>
+          <a:bodyPr wrap="square" lIns="0" tIns="0" rIns="0" bIns="0" rtlCol="0" anchor="b"/>
           <a:lstStyle/>
           <a:p>
             <a:pPr algn="r" indent="0" marL="0">
@@ -19052,6 +19052,45 @@
       <p:sp>
         <p:nvSpPr>
           <p:cNvPr id="14" name="Text 12"/>
+          <p:cNvSpPr txBox="1"/>
+          <p:nvPr/>
+        </p:nvSpPr>
+        <p:spPr>
+          <a:xfrm>
+            <a:off x="2941320" y="2583619"/>
+            <a:ext cx="1115568" cy="265103"/>
+          </a:xfrm>
+          <a:prstGeom prst="rect">
+            <a:avLst/>
+          </a:prstGeom>
+          <a:noFill/>
+          <a:ln/>
+        </p:spPr>
+        <p:txBody>
+          <a:bodyPr wrap="square" lIns="0" tIns="0" rIns="0" bIns="0" rtlCol="0" anchor="t"/>
+          <a:lstStyle/>
+          <a:p>
+            <a:pPr algn="r" indent="0" marL="0">
+              <a:buNone/>
+            </a:pPr>
+            <a:r>
+              <a:rPr lang="en-US" sz="1300" dirty="0">
+                <a:solidFill>
+                  <a:srgbClr val="595959"/>
+                </a:solidFill>
+                <a:latin typeface="Inter" pitchFamily="34" charset="0"/>
+                <a:ea typeface="Inter" pitchFamily="34" charset="-122"/>
+                <a:cs typeface="Inter" pitchFamily="34" charset="-120"/>
+              </a:rPr>
+              <a:t>+22.1%</a:t>
+            </a:r>
+            <a:endParaRPr lang="en-US" sz="1300" dirty="0"/>
+          </a:p>
+        </p:txBody>
+      </p:sp>
+      <p:sp>
+        <p:nvSpPr>
+          <p:cNvPr id="15" name="Text 13"/>
           <p:cNvSpPr txBox="1"/>
           <p:nvPr/>
         </p:nvSpPr>
@@ -19090,7 +19129,7 @@
       </p:sp>
       <p:sp>
         <p:nvSpPr>
-          <p:cNvPr id="15" name="Text 13"/>
+          <p:cNvPr id="16" name="Text 14"/>
           <p:cNvSpPr txBox="1"/>
           <p:nvPr/>
         </p:nvSpPr>
@@ -19169,23 +19208,23 @@
       </p:sp>
       <p:sp>
         <p:nvSpPr>
-          <p:cNvPr id="16" name="Text 14"/>
-          <p:cNvSpPr txBox="1"/>
-          <p:nvPr/>
-        </p:nvSpPr>
-        <p:spPr>
-          <a:xfrm>
-            <a:off x="2941320" y="2931566"/>
-            <a:ext cx="1115568" cy="828446"/>
-          </a:xfrm>
-          <a:prstGeom prst="rect">
-            <a:avLst/>
-          </a:prstGeom>
-          <a:noFill/>
-          <a:ln/>
-        </p:spPr>
-        <p:txBody>
-          <a:bodyPr wrap="square" lIns="0" tIns="0" rIns="0" bIns="0" rtlCol="0" anchor="ctr"/>
+          <p:cNvPr id="17" name="Text 15"/>
+          <p:cNvSpPr txBox="1"/>
+          <p:nvPr/>
+        </p:nvSpPr>
+        <p:spPr>
+          <a:xfrm>
+            <a:off x="2941320" y="3030980"/>
+            <a:ext cx="1115568" cy="414223"/>
+          </a:xfrm>
+          <a:prstGeom prst="rect">
+            <a:avLst/>
+          </a:prstGeom>
+          <a:noFill/>
+          <a:ln/>
+        </p:spPr>
+        <p:txBody>
+          <a:bodyPr wrap="square" lIns="0" tIns="0" rIns="0" bIns="0" rtlCol="0" anchor="b"/>
           <a:lstStyle/>
           <a:p>
             <a:pPr algn="r" indent="0" marL="0">
@@ -19208,7 +19247,46 @@
       </p:sp>
       <p:sp>
         <p:nvSpPr>
-          <p:cNvPr id="17" name="Shape 15"/>
+          <p:cNvPr id="18" name="Text 16"/>
+          <p:cNvSpPr txBox="1"/>
+          <p:nvPr/>
+        </p:nvSpPr>
+        <p:spPr>
+          <a:xfrm>
+            <a:off x="2941320" y="3412065"/>
+            <a:ext cx="1115568" cy="265103"/>
+          </a:xfrm>
+          <a:prstGeom prst="rect">
+            <a:avLst/>
+          </a:prstGeom>
+          <a:noFill/>
+          <a:ln/>
+        </p:spPr>
+        <p:txBody>
+          <a:bodyPr wrap="square" lIns="0" tIns="0" rIns="0" bIns="0" rtlCol="0" anchor="t"/>
+          <a:lstStyle/>
+          <a:p>
+            <a:pPr algn="r" indent="0" marL="0">
+              <a:buNone/>
+            </a:pPr>
+            <a:r>
+              <a:rPr lang="en-US" sz="1300" dirty="0">
+                <a:solidFill>
+                  <a:srgbClr val="595959"/>
+                </a:solidFill>
+                <a:latin typeface="Inter" pitchFamily="34" charset="0"/>
+                <a:ea typeface="Inter" pitchFamily="34" charset="-122"/>
+                <a:cs typeface="Inter" pitchFamily="34" charset="-120"/>
+              </a:rPr>
+              <a:t>+20.4%</a:t>
+            </a:r>
+            <a:endParaRPr lang="en-US" sz="1300" dirty="0"/>
+          </a:p>
+        </p:txBody>
+      </p:sp>
+      <p:sp>
+        <p:nvSpPr>
+          <p:cNvPr id="19" name="Shape 17"/>
           <p:cNvSpPr/>
           <p:nvPr/>
         </p:nvSpPr>
@@ -19228,7 +19306,7 @@
       </p:sp>
       <p:sp>
         <p:nvSpPr>
-          <p:cNvPr id="18" name="Text 16"/>
+          <p:cNvPr id="20" name="Text 18"/>
           <p:cNvSpPr txBox="1"/>
           <p:nvPr/>
         </p:nvSpPr>
@@ -19267,7 +19345,7 @@
       </p:sp>
       <p:sp>
         <p:nvSpPr>
-          <p:cNvPr id="19" name="Text 17"/>
+          <p:cNvPr id="21" name="Text 19"/>
           <p:cNvSpPr txBox="1"/>
           <p:nvPr/>
         </p:nvSpPr>
@@ -19346,23 +19424,23 @@
       </p:sp>
       <p:sp>
         <p:nvSpPr>
-          <p:cNvPr id="20" name="Text 18"/>
-          <p:cNvSpPr txBox="1"/>
-          <p:nvPr/>
-        </p:nvSpPr>
-        <p:spPr>
-          <a:xfrm>
-            <a:off x="2941320" y="3760013"/>
-            <a:ext cx="1115568" cy="828446"/>
-          </a:xfrm>
-          <a:prstGeom prst="rect">
-            <a:avLst/>
-          </a:prstGeom>
-          <a:noFill/>
-          <a:ln/>
-        </p:spPr>
-        <p:txBody>
-          <a:bodyPr wrap="square" lIns="0" tIns="0" rIns="0" bIns="0" rtlCol="0" anchor="ctr"/>
+          <p:cNvPr id="22" name="Text 20"/>
+          <p:cNvSpPr txBox="1"/>
+          <p:nvPr/>
+        </p:nvSpPr>
+        <p:spPr>
+          <a:xfrm>
+            <a:off x="2941320" y="3859426"/>
+            <a:ext cx="1115568" cy="414223"/>
+          </a:xfrm>
+          <a:prstGeom prst="rect">
+            <a:avLst/>
+          </a:prstGeom>
+          <a:noFill/>
+          <a:ln/>
+        </p:spPr>
+        <p:txBody>
+          <a:bodyPr wrap="square" lIns="0" tIns="0" rIns="0" bIns="0" rtlCol="0" anchor="b"/>
           <a:lstStyle/>
           <a:p>
             <a:pPr algn="r" indent="0" marL="0">
@@ -19385,7 +19463,46 @@
       </p:sp>
       <p:sp>
         <p:nvSpPr>
-          <p:cNvPr id="21" name="Shape 19"/>
+          <p:cNvPr id="23" name="Text 21"/>
+          <p:cNvSpPr txBox="1"/>
+          <p:nvPr/>
+        </p:nvSpPr>
+        <p:spPr>
+          <a:xfrm>
+            <a:off x="2941320" y="4240512"/>
+            <a:ext cx="1115568" cy="265103"/>
+          </a:xfrm>
+          <a:prstGeom prst="rect">
+            <a:avLst/>
+          </a:prstGeom>
+          <a:noFill/>
+          <a:ln/>
+        </p:spPr>
+        <p:txBody>
+          <a:bodyPr wrap="square" lIns="0" tIns="0" rIns="0" bIns="0" rtlCol="0" anchor="t"/>
+          <a:lstStyle/>
+          <a:p>
+            <a:pPr algn="r" indent="0" marL="0">
+              <a:buNone/>
+            </a:pPr>
+            <a:r>
+              <a:rPr lang="en-US" sz="1300" dirty="0">
+                <a:solidFill>
+                  <a:srgbClr val="595959"/>
+                </a:solidFill>
+                <a:latin typeface="Inter" pitchFamily="34" charset="0"/>
+                <a:ea typeface="Inter" pitchFamily="34" charset="-122"/>
+                <a:cs typeface="Inter" pitchFamily="34" charset="-120"/>
+              </a:rPr>
+              <a:t>+41.8%</a:t>
+            </a:r>
+            <a:endParaRPr lang="en-US" sz="1300" dirty="0"/>
+          </a:p>
+        </p:txBody>
+      </p:sp>
+      <p:sp>
+        <p:nvSpPr>
+          <p:cNvPr id="24" name="Shape 22"/>
           <p:cNvSpPr/>
           <p:nvPr/>
         </p:nvSpPr>
@@ -19405,7 +19522,7 @@
       </p:sp>
       <p:sp>
         <p:nvSpPr>
-          <p:cNvPr id="22" name="Text 20"/>
+          <p:cNvPr id="25" name="Text 23"/>
           <p:cNvSpPr txBox="1"/>
           <p:nvPr/>
         </p:nvSpPr>
@@ -19444,7 +19561,7 @@
       </p:sp>
       <p:sp>
         <p:nvSpPr>
-          <p:cNvPr id="23" name="Text 21"/>
+          <p:cNvPr id="26" name="Text 24"/>
           <p:cNvSpPr txBox="1"/>
           <p:nvPr/>
         </p:nvSpPr>
@@ -19523,23 +19640,23 @@
       </p:sp>
       <p:sp>
         <p:nvSpPr>
-          <p:cNvPr id="24" name="Text 22"/>
-          <p:cNvSpPr txBox="1"/>
-          <p:nvPr/>
-        </p:nvSpPr>
-        <p:spPr>
-          <a:xfrm>
-            <a:off x="2941320" y="4588459"/>
-            <a:ext cx="1115568" cy="828446"/>
-          </a:xfrm>
-          <a:prstGeom prst="rect">
-            <a:avLst/>
-          </a:prstGeom>
-          <a:noFill/>
-          <a:ln/>
-        </p:spPr>
-        <p:txBody>
-          <a:bodyPr wrap="square" lIns="0" tIns="0" rIns="0" bIns="0" rtlCol="0" anchor="ctr"/>
+          <p:cNvPr id="27" name="Text 25"/>
+          <p:cNvSpPr txBox="1"/>
+          <p:nvPr/>
+        </p:nvSpPr>
+        <p:spPr>
+          <a:xfrm>
+            <a:off x="2941320" y="4687873"/>
+            <a:ext cx="1115568" cy="414223"/>
+          </a:xfrm>
+          <a:prstGeom prst="rect">
+            <a:avLst/>
+          </a:prstGeom>
+          <a:noFill/>
+          <a:ln/>
+        </p:spPr>
+        <p:txBody>
+          <a:bodyPr wrap="square" lIns="0" tIns="0" rIns="0" bIns="0" rtlCol="0" anchor="b"/>
           <a:lstStyle/>
           <a:p>
             <a:pPr algn="r" indent="0" marL="0">
@@ -19562,7 +19679,46 @@
       </p:sp>
       <p:sp>
         <p:nvSpPr>
-          <p:cNvPr id="25" name="Shape 23"/>
+          <p:cNvPr id="28" name="Text 26"/>
+          <p:cNvSpPr txBox="1"/>
+          <p:nvPr/>
+        </p:nvSpPr>
+        <p:spPr>
+          <a:xfrm>
+            <a:off x="2941320" y="5068958"/>
+            <a:ext cx="1115568" cy="265103"/>
+          </a:xfrm>
+          <a:prstGeom prst="rect">
+            <a:avLst/>
+          </a:prstGeom>
+          <a:noFill/>
+          <a:ln/>
+        </p:spPr>
+        <p:txBody>
+          <a:bodyPr wrap="square" lIns="0" tIns="0" rIns="0" bIns="0" rtlCol="0" anchor="t"/>
+          <a:lstStyle/>
+          <a:p>
+            <a:pPr algn="r" indent="0" marL="0">
+              <a:buNone/>
+            </a:pPr>
+            <a:r>
+              <a:rPr lang="en-US" sz="1300" dirty="0">
+                <a:solidFill>
+                  <a:srgbClr val="595959"/>
+                </a:solidFill>
+                <a:latin typeface="Inter" pitchFamily="34" charset="0"/>
+                <a:ea typeface="Inter" pitchFamily="34" charset="-122"/>
+                <a:cs typeface="Inter" pitchFamily="34" charset="-120"/>
+              </a:rPr>
+              <a:t>+12.9%</a:t>
+            </a:r>
+            <a:endParaRPr lang="en-US" sz="1300" dirty="0"/>
+          </a:p>
+        </p:txBody>
+      </p:sp>
+      <p:sp>
+        <p:nvSpPr>
+          <p:cNvPr id="29" name="Shape 27"/>
           <p:cNvSpPr/>
           <p:nvPr/>
         </p:nvSpPr>
@@ -19582,7 +19738,7 @@
       </p:sp>
       <p:sp>
         <p:nvSpPr>
-          <p:cNvPr id="26" name="Text 24"/>
+          <p:cNvPr id="30" name="Text 28"/>
           <p:cNvSpPr txBox="1"/>
           <p:nvPr/>
         </p:nvSpPr>
@@ -19621,7 +19777,7 @@
       </p:sp>
       <p:sp>
         <p:nvSpPr>
-          <p:cNvPr id="27" name="Text 25"/>
+          <p:cNvPr id="31" name="Text 29"/>
           <p:cNvSpPr txBox="1"/>
           <p:nvPr/>
         </p:nvSpPr>
@@ -19700,23 +19856,23 @@
       </p:sp>
       <p:sp>
         <p:nvSpPr>
-          <p:cNvPr id="28" name="Text 26"/>
-          <p:cNvSpPr txBox="1"/>
-          <p:nvPr/>
-        </p:nvSpPr>
-        <p:spPr>
-          <a:xfrm>
-            <a:off x="2941320" y="5416906"/>
-            <a:ext cx="1115568" cy="828446"/>
-          </a:xfrm>
-          <a:prstGeom prst="rect">
-            <a:avLst/>
-          </a:prstGeom>
-          <a:noFill/>
-          <a:ln/>
-        </p:spPr>
-        <p:txBody>
-          <a:bodyPr wrap="square" lIns="0" tIns="0" rIns="0" bIns="0" rtlCol="0" anchor="ctr"/>
+          <p:cNvPr id="32" name="Text 30"/>
+          <p:cNvSpPr txBox="1"/>
+          <p:nvPr/>
+        </p:nvSpPr>
+        <p:spPr>
+          <a:xfrm>
+            <a:off x="2941320" y="5516319"/>
+            <a:ext cx="1115568" cy="414223"/>
+          </a:xfrm>
+          <a:prstGeom prst="rect">
+            <a:avLst/>
+          </a:prstGeom>
+          <a:noFill/>
+          <a:ln/>
+        </p:spPr>
+        <p:txBody>
+          <a:bodyPr wrap="square" lIns="0" tIns="0" rIns="0" bIns="0" rtlCol="0" anchor="b"/>
           <a:lstStyle/>
           <a:p>
             <a:pPr algn="r" indent="0" marL="0">
@@ -19739,7 +19895,46 @@
       </p:sp>
       <p:sp>
         <p:nvSpPr>
-          <p:cNvPr id="29" name="Shape 27"/>
+          <p:cNvPr id="33" name="Text 31"/>
+          <p:cNvSpPr txBox="1"/>
+          <p:nvPr/>
+        </p:nvSpPr>
+        <p:spPr>
+          <a:xfrm>
+            <a:off x="2941320" y="5897405"/>
+            <a:ext cx="1115568" cy="265103"/>
+          </a:xfrm>
+          <a:prstGeom prst="rect">
+            <a:avLst/>
+          </a:prstGeom>
+          <a:noFill/>
+          <a:ln/>
+        </p:spPr>
+        <p:txBody>
+          <a:bodyPr wrap="square" lIns="0" tIns="0" rIns="0" bIns="0" rtlCol="0" anchor="t"/>
+          <a:lstStyle/>
+          <a:p>
+            <a:pPr algn="r" indent="0" marL="0">
+              <a:buNone/>
+            </a:pPr>
+            <a:r>
+              <a:rPr lang="en-US" sz="1300" dirty="0">
+                <a:solidFill>
+                  <a:srgbClr val="595959"/>
+                </a:solidFill>
+                <a:latin typeface="Inter" pitchFamily="34" charset="0"/>
+                <a:ea typeface="Inter" pitchFamily="34" charset="-122"/>
+                <a:cs typeface="Inter" pitchFamily="34" charset="-120"/>
+              </a:rPr>
+              <a:t>+124.3%</a:t>
+            </a:r>
+            <a:endParaRPr lang="en-US" sz="1300" dirty="0"/>
+          </a:p>
+        </p:txBody>
+      </p:sp>
+      <p:sp>
+        <p:nvSpPr>
+          <p:cNvPr id="34" name="Shape 32"/>
           <p:cNvSpPr/>
           <p:nvPr/>
         </p:nvSpPr>
@@ -19759,7 +19954,7 @@
       </p:sp>
       <p:sp>
         <p:nvSpPr>
-          <p:cNvPr id="30" name="Text 28"/>
+          <p:cNvPr id="35" name="Text 33"/>
           <p:cNvSpPr txBox="1"/>
           <p:nvPr/>
         </p:nvSpPr>
@@ -19798,7 +19993,7 @@
       </p:sp>
       <p:sp>
         <p:nvSpPr>
-          <p:cNvPr id="31" name="Text 29"/>
+          <p:cNvPr id="36" name="Text 34"/>
           <p:cNvSpPr txBox="1"/>
           <p:nvPr/>
         </p:nvSpPr>
@@ -19837,7 +20032,7 @@
       </p:sp>
       <p:sp>
         <p:nvSpPr>
-          <p:cNvPr id="32" name="Shape 30"/>
+          <p:cNvPr id="37" name="Shape 35"/>
           <p:cNvSpPr/>
           <p:nvPr/>
         </p:nvSpPr>
@@ -19857,7 +20052,7 @@
       </p:sp>
       <p:sp>
         <p:nvSpPr>
-          <p:cNvPr id="33" name="Shape 31"/>
+          <p:cNvPr id="38" name="Shape 36"/>
           <p:cNvSpPr/>
           <p:nvPr/>
         </p:nvSpPr>
@@ -19877,7 +20072,7 @@
       </p:sp>
       <p:sp>
         <p:nvSpPr>
-          <p:cNvPr id="34" name="Text 32"/>
+          <p:cNvPr id="39" name="Text 37"/>
           <p:cNvSpPr txBox="1"/>
           <p:nvPr/>
         </p:nvSpPr>
@@ -19916,7 +20111,7 @@
       </p:sp>
       <p:sp>
         <p:nvSpPr>
-          <p:cNvPr id="35" name="Text 33"/>
+          <p:cNvPr id="40" name="Text 38"/>
           <p:cNvSpPr txBox="1"/>
           <p:nvPr/>
         </p:nvSpPr>
@@ -19995,23 +20190,23 @@
       </p:sp>
       <p:sp>
         <p:nvSpPr>
-          <p:cNvPr id="36" name="Text 34"/>
-          <p:cNvSpPr txBox="1"/>
-          <p:nvPr/>
-        </p:nvSpPr>
-        <p:spPr>
-          <a:xfrm>
-            <a:off x="6632448" y="2103120"/>
-            <a:ext cx="1115568" cy="828446"/>
-          </a:xfrm>
-          <a:prstGeom prst="rect">
-            <a:avLst/>
-          </a:prstGeom>
-          <a:noFill/>
-          <a:ln/>
-        </p:spPr>
-        <p:txBody>
-          <a:bodyPr wrap="square" lIns="0" tIns="0" rIns="0" bIns="0" rtlCol="0" anchor="ctr"/>
+          <p:cNvPr id="41" name="Text 39"/>
+          <p:cNvSpPr txBox="1"/>
+          <p:nvPr/>
+        </p:nvSpPr>
+        <p:spPr>
+          <a:xfrm>
+            <a:off x="6632448" y="2202534"/>
+            <a:ext cx="1115568" cy="414223"/>
+          </a:xfrm>
+          <a:prstGeom prst="rect">
+            <a:avLst/>
+          </a:prstGeom>
+          <a:noFill/>
+          <a:ln/>
+        </p:spPr>
+        <p:txBody>
+          <a:bodyPr wrap="square" lIns="0" tIns="0" rIns="0" bIns="0" rtlCol="0" anchor="b"/>
           <a:lstStyle/>
           <a:p>
             <a:pPr algn="r" indent="0" marL="0">
@@ -20034,7 +20229,46 @@
       </p:sp>
       <p:sp>
         <p:nvSpPr>
-          <p:cNvPr id="37" name="Text 35"/>
+          <p:cNvPr id="42" name="Text 40"/>
+          <p:cNvSpPr txBox="1"/>
+          <p:nvPr/>
+        </p:nvSpPr>
+        <p:spPr>
+          <a:xfrm>
+            <a:off x="6632448" y="2583619"/>
+            <a:ext cx="1115568" cy="265103"/>
+          </a:xfrm>
+          <a:prstGeom prst="rect">
+            <a:avLst/>
+          </a:prstGeom>
+          <a:noFill/>
+          <a:ln/>
+        </p:spPr>
+        <p:txBody>
+          <a:bodyPr wrap="square" lIns="0" tIns="0" rIns="0" bIns="0" rtlCol="0" anchor="t"/>
+          <a:lstStyle/>
+          <a:p>
+            <a:pPr algn="r" indent="0" marL="0">
+              <a:buNone/>
+            </a:pPr>
+            <a:r>
+              <a:rPr lang="en-US" sz="1300" dirty="0">
+                <a:solidFill>
+                  <a:srgbClr val="595959"/>
+                </a:solidFill>
+                <a:latin typeface="Inter" pitchFamily="34" charset="0"/>
+                <a:ea typeface="Inter" pitchFamily="34" charset="-122"/>
+                <a:cs typeface="Inter" pitchFamily="34" charset="-120"/>
+              </a:rPr>
+              <a:t>−22.1%</a:t>
+            </a:r>
+            <a:endParaRPr lang="en-US" sz="1300" dirty="0"/>
+          </a:p>
+        </p:txBody>
+      </p:sp>
+      <p:sp>
+        <p:nvSpPr>
+          <p:cNvPr id="43" name="Text 41"/>
           <p:cNvSpPr txBox="1"/>
           <p:nvPr/>
         </p:nvSpPr>
@@ -20073,7 +20307,7 @@
       </p:sp>
       <p:sp>
         <p:nvSpPr>
-          <p:cNvPr id="38" name="Text 36"/>
+          <p:cNvPr id="44" name="Text 42"/>
           <p:cNvSpPr txBox="1"/>
           <p:nvPr/>
         </p:nvSpPr>
@@ -20152,23 +20386,23 @@
       </p:sp>
       <p:sp>
         <p:nvSpPr>
-          <p:cNvPr id="39" name="Text 37"/>
-          <p:cNvSpPr txBox="1"/>
-          <p:nvPr/>
-        </p:nvSpPr>
-        <p:spPr>
-          <a:xfrm>
-            <a:off x="6632448" y="2931566"/>
-            <a:ext cx="1115568" cy="828446"/>
-          </a:xfrm>
-          <a:prstGeom prst="rect">
-            <a:avLst/>
-          </a:prstGeom>
-          <a:noFill/>
-          <a:ln/>
-        </p:spPr>
-        <p:txBody>
-          <a:bodyPr wrap="square" lIns="0" tIns="0" rIns="0" bIns="0" rtlCol="0" anchor="ctr"/>
+          <p:cNvPr id="45" name="Text 43"/>
+          <p:cNvSpPr txBox="1"/>
+          <p:nvPr/>
+        </p:nvSpPr>
+        <p:spPr>
+          <a:xfrm>
+            <a:off x="6632448" y="3030980"/>
+            <a:ext cx="1115568" cy="414223"/>
+          </a:xfrm>
+          <a:prstGeom prst="rect">
+            <a:avLst/>
+          </a:prstGeom>
+          <a:noFill/>
+          <a:ln/>
+        </p:spPr>
+        <p:txBody>
+          <a:bodyPr wrap="square" lIns="0" tIns="0" rIns="0" bIns="0" rtlCol="0" anchor="b"/>
           <a:lstStyle/>
           <a:p>
             <a:pPr algn="r" indent="0" marL="0">
@@ -20191,7 +20425,46 @@
       </p:sp>
       <p:sp>
         <p:nvSpPr>
-          <p:cNvPr id="40" name="Shape 38"/>
+          <p:cNvPr id="46" name="Text 44"/>
+          <p:cNvSpPr txBox="1"/>
+          <p:nvPr/>
+        </p:nvSpPr>
+        <p:spPr>
+          <a:xfrm>
+            <a:off x="6632448" y="3412065"/>
+            <a:ext cx="1115568" cy="265103"/>
+          </a:xfrm>
+          <a:prstGeom prst="rect">
+            <a:avLst/>
+          </a:prstGeom>
+          <a:noFill/>
+          <a:ln/>
+        </p:spPr>
+        <p:txBody>
+          <a:bodyPr wrap="square" lIns="0" tIns="0" rIns="0" bIns="0" rtlCol="0" anchor="t"/>
+          <a:lstStyle/>
+          <a:p>
+            <a:pPr algn="r" indent="0" marL="0">
+              <a:buNone/>
+            </a:pPr>
+            <a:r>
+              <a:rPr lang="en-US" sz="1300" dirty="0">
+                <a:solidFill>
+                  <a:srgbClr val="595959"/>
+                </a:solidFill>
+                <a:latin typeface="Inter" pitchFamily="34" charset="0"/>
+                <a:ea typeface="Inter" pitchFamily="34" charset="-122"/>
+                <a:cs typeface="Inter" pitchFamily="34" charset="-120"/>
+              </a:rPr>
+              <a:t>−29.6%</a:t>
+            </a:r>
+            <a:endParaRPr lang="en-US" sz="1300" dirty="0"/>
+          </a:p>
+        </p:txBody>
+      </p:sp>
+      <p:sp>
+        <p:nvSpPr>
+          <p:cNvPr id="47" name="Shape 45"/>
           <p:cNvSpPr/>
           <p:nvPr/>
         </p:nvSpPr>
@@ -20211,7 +20484,7 @@
       </p:sp>
       <p:sp>
         <p:nvSpPr>
-          <p:cNvPr id="41" name="Text 39"/>
+          <p:cNvPr id="48" name="Text 46"/>
           <p:cNvSpPr txBox="1"/>
           <p:nvPr/>
         </p:nvSpPr>
@@ -20250,7 +20523,7 @@
       </p:sp>
       <p:sp>
         <p:nvSpPr>
-          <p:cNvPr id="42" name="Text 40"/>
+          <p:cNvPr id="49" name="Text 47"/>
           <p:cNvSpPr txBox="1"/>
           <p:nvPr/>
         </p:nvSpPr>
@@ -20329,23 +20602,23 @@
       </p:sp>
       <p:sp>
         <p:nvSpPr>
-          <p:cNvPr id="43" name="Text 41"/>
-          <p:cNvSpPr txBox="1"/>
-          <p:nvPr/>
-        </p:nvSpPr>
-        <p:spPr>
-          <a:xfrm>
-            <a:off x="6632448" y="3760013"/>
-            <a:ext cx="1115568" cy="828446"/>
-          </a:xfrm>
-          <a:prstGeom prst="rect">
-            <a:avLst/>
-          </a:prstGeom>
-          <a:noFill/>
-          <a:ln/>
-        </p:spPr>
-        <p:txBody>
-          <a:bodyPr wrap="square" lIns="0" tIns="0" rIns="0" bIns="0" rtlCol="0" anchor="ctr"/>
+          <p:cNvPr id="50" name="Text 48"/>
+          <p:cNvSpPr txBox="1"/>
+          <p:nvPr/>
+        </p:nvSpPr>
+        <p:spPr>
+          <a:xfrm>
+            <a:off x="6632448" y="3859426"/>
+            <a:ext cx="1115568" cy="414223"/>
+          </a:xfrm>
+          <a:prstGeom prst="rect">
+            <a:avLst/>
+          </a:prstGeom>
+          <a:noFill/>
+          <a:ln/>
+        </p:spPr>
+        <p:txBody>
+          <a:bodyPr wrap="square" lIns="0" tIns="0" rIns="0" bIns="0" rtlCol="0" anchor="b"/>
           <a:lstStyle/>
           <a:p>
             <a:pPr algn="r" indent="0" marL="0">
@@ -20368,7 +20641,46 @@
       </p:sp>
       <p:sp>
         <p:nvSpPr>
-          <p:cNvPr id="44" name="Text 42"/>
+          <p:cNvPr id="51" name="Text 49"/>
+          <p:cNvSpPr txBox="1"/>
+          <p:nvPr/>
+        </p:nvSpPr>
+        <p:spPr>
+          <a:xfrm>
+            <a:off x="6632448" y="4240512"/>
+            <a:ext cx="1115568" cy="265103"/>
+          </a:xfrm>
+          <a:prstGeom prst="rect">
+            <a:avLst/>
+          </a:prstGeom>
+          <a:noFill/>
+          <a:ln/>
+        </p:spPr>
+        <p:txBody>
+          <a:bodyPr wrap="square" lIns="0" tIns="0" rIns="0" bIns="0" rtlCol="0" anchor="t"/>
+          <a:lstStyle/>
+          <a:p>
+            <a:pPr algn="r" indent="0" marL="0">
+              <a:buNone/>
+            </a:pPr>
+            <a:r>
+              <a:rPr lang="en-US" sz="1300" dirty="0">
+                <a:solidFill>
+                  <a:srgbClr val="595959"/>
+                </a:solidFill>
+                <a:latin typeface="Inter" pitchFamily="34" charset="0"/>
+                <a:ea typeface="Inter" pitchFamily="34" charset="-122"/>
+                <a:cs typeface="Inter" pitchFamily="34" charset="-120"/>
+              </a:rPr>
+              <a:t>−27.7%</a:t>
+            </a:r>
+            <a:endParaRPr lang="en-US" sz="1300" dirty="0"/>
+          </a:p>
+        </p:txBody>
+      </p:sp>
+      <p:sp>
+        <p:nvSpPr>
+          <p:cNvPr id="52" name="Text 50"/>
           <p:cNvSpPr txBox="1"/>
           <p:nvPr/>
         </p:nvSpPr>
@@ -20407,7 +20719,7 @@
       </p:sp>
       <p:sp>
         <p:nvSpPr>
-          <p:cNvPr id="45" name="Text 43"/>
+          <p:cNvPr id="53" name="Text 51"/>
           <p:cNvSpPr txBox="1"/>
           <p:nvPr/>
         </p:nvSpPr>
@@ -20486,23 +20798,23 @@
       </p:sp>
       <p:sp>
         <p:nvSpPr>
-          <p:cNvPr id="46" name="Text 44"/>
-          <p:cNvSpPr txBox="1"/>
-          <p:nvPr/>
-        </p:nvSpPr>
-        <p:spPr>
-          <a:xfrm>
-            <a:off x="6632448" y="4588459"/>
-            <a:ext cx="1115568" cy="828446"/>
-          </a:xfrm>
-          <a:prstGeom prst="rect">
-            <a:avLst/>
-          </a:prstGeom>
-          <a:noFill/>
-          <a:ln/>
-        </p:spPr>
-        <p:txBody>
-          <a:bodyPr wrap="square" lIns="0" tIns="0" rIns="0" bIns="0" rtlCol="0" anchor="ctr"/>
+          <p:cNvPr id="54" name="Text 52"/>
+          <p:cNvSpPr txBox="1"/>
+          <p:nvPr/>
+        </p:nvSpPr>
+        <p:spPr>
+          <a:xfrm>
+            <a:off x="6632448" y="4687873"/>
+            <a:ext cx="1115568" cy="414223"/>
+          </a:xfrm>
+          <a:prstGeom prst="rect">
+            <a:avLst/>
+          </a:prstGeom>
+          <a:noFill/>
+          <a:ln/>
+        </p:spPr>
+        <p:txBody>
+          <a:bodyPr wrap="square" lIns="0" tIns="0" rIns="0" bIns="0" rtlCol="0" anchor="b"/>
           <a:lstStyle/>
           <a:p>
             <a:pPr algn="r" indent="0" marL="0">
@@ -20525,7 +20837,46 @@
       </p:sp>
       <p:sp>
         <p:nvSpPr>
-          <p:cNvPr id="47" name="Shape 45"/>
+          <p:cNvPr id="55" name="Text 53"/>
+          <p:cNvSpPr txBox="1"/>
+          <p:nvPr/>
+        </p:nvSpPr>
+        <p:spPr>
+          <a:xfrm>
+            <a:off x="6632448" y="5068958"/>
+            <a:ext cx="1115568" cy="265103"/>
+          </a:xfrm>
+          <a:prstGeom prst="rect">
+            <a:avLst/>
+          </a:prstGeom>
+          <a:noFill/>
+          <a:ln/>
+        </p:spPr>
+        <p:txBody>
+          <a:bodyPr wrap="square" lIns="0" tIns="0" rIns="0" bIns="0" rtlCol="0" anchor="t"/>
+          <a:lstStyle/>
+          <a:p>
+            <a:pPr algn="r" indent="0" marL="0">
+              <a:buNone/>
+            </a:pPr>
+            <a:r>
+              <a:rPr lang="en-US" sz="1300" dirty="0">
+                <a:solidFill>
+                  <a:srgbClr val="595959"/>
+                </a:solidFill>
+                <a:latin typeface="Inter" pitchFamily="34" charset="0"/>
+                <a:ea typeface="Inter" pitchFamily="34" charset="-122"/>
+                <a:cs typeface="Inter" pitchFamily="34" charset="-120"/>
+              </a:rPr>
+              <a:t>−138.2%</a:t>
+            </a:r>
+            <a:endParaRPr lang="en-US" sz="1300" dirty="0"/>
+          </a:p>
+        </p:txBody>
+      </p:sp>
+      <p:sp>
+        <p:nvSpPr>
+          <p:cNvPr id="56" name="Shape 54"/>
           <p:cNvSpPr/>
           <p:nvPr/>
         </p:nvSpPr>
@@ -20545,7 +20896,7 @@
       </p:sp>
       <p:sp>
         <p:nvSpPr>
-          <p:cNvPr id="48" name="Text 46"/>
+          <p:cNvPr id="57" name="Text 55"/>
           <p:cNvSpPr txBox="1"/>
           <p:nvPr/>
         </p:nvSpPr>
@@ -20584,7 +20935,7 @@
       </p:sp>
       <p:sp>
         <p:nvSpPr>
-          <p:cNvPr id="49" name="Text 47"/>
+          <p:cNvPr id="58" name="Text 56"/>
           <p:cNvSpPr txBox="1"/>
           <p:nvPr/>
         </p:nvSpPr>
@@ -20663,23 +21014,23 @@
       </p:sp>
       <p:sp>
         <p:nvSpPr>
-          <p:cNvPr id="50" name="Text 48"/>
-          <p:cNvSpPr txBox="1"/>
-          <p:nvPr/>
-        </p:nvSpPr>
-        <p:spPr>
-          <a:xfrm>
-            <a:off x="6632448" y="5416906"/>
-            <a:ext cx="1115568" cy="828446"/>
-          </a:xfrm>
-          <a:prstGeom prst="rect">
-            <a:avLst/>
-          </a:prstGeom>
-          <a:noFill/>
-          <a:ln/>
-        </p:spPr>
-        <p:txBody>
-          <a:bodyPr wrap="square" lIns="0" tIns="0" rIns="0" bIns="0" rtlCol="0" anchor="ctr"/>
+          <p:cNvPr id="59" name="Text 57"/>
+          <p:cNvSpPr txBox="1"/>
+          <p:nvPr/>
+        </p:nvSpPr>
+        <p:spPr>
+          <a:xfrm>
+            <a:off x="6632448" y="5516319"/>
+            <a:ext cx="1115568" cy="414223"/>
+          </a:xfrm>
+          <a:prstGeom prst="rect">
+            <a:avLst/>
+          </a:prstGeom>
+          <a:noFill/>
+          <a:ln/>
+        </p:spPr>
+        <p:txBody>
+          <a:bodyPr wrap="square" lIns="0" tIns="0" rIns="0" bIns="0" rtlCol="0" anchor="b"/>
           <a:lstStyle/>
           <a:p>
             <a:pPr algn="r" indent="0" marL="0">
@@ -20702,7 +21053,46 @@
       </p:sp>
       <p:sp>
         <p:nvSpPr>
-          <p:cNvPr id="51" name="Shape 49"/>
+          <p:cNvPr id="60" name="Text 58"/>
+          <p:cNvSpPr txBox="1"/>
+          <p:nvPr/>
+        </p:nvSpPr>
+        <p:spPr>
+          <a:xfrm>
+            <a:off x="6632448" y="5897405"/>
+            <a:ext cx="1115568" cy="265103"/>
+          </a:xfrm>
+          <a:prstGeom prst="rect">
+            <a:avLst/>
+          </a:prstGeom>
+          <a:noFill/>
+          <a:ln/>
+        </p:spPr>
+        <p:txBody>
+          <a:bodyPr wrap="square" lIns="0" tIns="0" rIns="0" bIns="0" rtlCol="0" anchor="t"/>
+          <a:lstStyle/>
+          <a:p>
+            <a:pPr algn="r" indent="0" marL="0">
+              <a:buNone/>
+            </a:pPr>
+            <a:r>
+              <a:rPr lang="en-US" sz="1300" dirty="0">
+                <a:solidFill>
+                  <a:srgbClr val="595959"/>
+                </a:solidFill>
+                <a:latin typeface="Inter" pitchFamily="34" charset="0"/>
+                <a:ea typeface="Inter" pitchFamily="34" charset="-122"/>
+                <a:cs typeface="Inter" pitchFamily="34" charset="-120"/>
+              </a:rPr>
+              <a:t>−8.9%</a:t>
+            </a:r>
+            <a:endParaRPr lang="en-US" sz="1300" dirty="0"/>
+          </a:p>
+        </p:txBody>
+      </p:sp>
+      <p:sp>
+        <p:nvSpPr>
+          <p:cNvPr id="61" name="Shape 59"/>
           <p:cNvSpPr/>
           <p:nvPr/>
         </p:nvSpPr>
@@ -20722,7 +21112,7 @@
       </p:sp>
       <p:sp>
         <p:nvSpPr>
-          <p:cNvPr id="52" name="Text 50"/>
+          <p:cNvPr id="62" name="Text 60"/>
           <p:cNvSpPr txBox="1"/>
           <p:nvPr/>
         </p:nvSpPr>
@@ -20761,7 +21151,7 @@
       </p:sp>
       <p:sp>
         <p:nvSpPr>
-          <p:cNvPr id="53" name="Text 51"/>
+          <p:cNvPr id="63" name="Text 61"/>
           <p:cNvSpPr txBox="1"/>
           <p:nvPr/>
         </p:nvSpPr>
@@ -20800,7 +21190,7 @@
       </p:sp>
       <p:sp>
         <p:nvSpPr>
-          <p:cNvPr id="54" name="Shape 52"/>
+          <p:cNvPr id="64" name="Shape 62"/>
           <p:cNvSpPr/>
           <p:nvPr/>
         </p:nvSpPr>
@@ -20820,7 +21210,7 @@
       </p:sp>
       <p:sp>
         <p:nvSpPr>
-          <p:cNvPr id="55" name="Shape 53"/>
+          <p:cNvPr id="65" name="Shape 63"/>
           <p:cNvSpPr/>
           <p:nvPr/>
         </p:nvSpPr>
@@ -20840,7 +21230,7 @@
       </p:sp>
       <p:sp>
         <p:nvSpPr>
-          <p:cNvPr id="56" name="Text 54"/>
+          <p:cNvPr id="66" name="Text 64"/>
           <p:cNvSpPr txBox="1"/>
           <p:nvPr/>
         </p:nvSpPr>
@@ -20879,7 +21269,7 @@
       </p:sp>
       <p:sp>
         <p:nvSpPr>
-          <p:cNvPr id="57" name="Text 55"/>
+          <p:cNvPr id="67" name="Text 65"/>
           <p:cNvSpPr txBox="1"/>
           <p:nvPr/>
         </p:nvSpPr>
@@ -20958,23 +21348,23 @@
       </p:sp>
       <p:sp>
         <p:nvSpPr>
-          <p:cNvPr id="58" name="Text 56"/>
-          <p:cNvSpPr txBox="1"/>
-          <p:nvPr/>
-        </p:nvSpPr>
-        <p:spPr>
-          <a:xfrm>
-            <a:off x="10323576" y="2103120"/>
-            <a:ext cx="1115568" cy="828446"/>
-          </a:xfrm>
-          <a:prstGeom prst="rect">
-            <a:avLst/>
-          </a:prstGeom>
-          <a:noFill/>
-          <a:ln/>
-        </p:spPr>
-        <p:txBody>
-          <a:bodyPr wrap="square" lIns="0" tIns="0" rIns="0" bIns="0" rtlCol="0" anchor="ctr"/>
+          <p:cNvPr id="68" name="Text 66"/>
+          <p:cNvSpPr txBox="1"/>
+          <p:nvPr/>
+        </p:nvSpPr>
+        <p:spPr>
+          <a:xfrm>
+            <a:off x="10323576" y="2202534"/>
+            <a:ext cx="1115568" cy="414223"/>
+          </a:xfrm>
+          <a:prstGeom prst="rect">
+            <a:avLst/>
+          </a:prstGeom>
+          <a:noFill/>
+          <a:ln/>
+        </p:spPr>
+        <p:txBody>
+          <a:bodyPr wrap="square" lIns="0" tIns="0" rIns="0" bIns="0" rtlCol="0" anchor="b"/>
           <a:lstStyle/>
           <a:p>
             <a:pPr algn="r" indent="0" marL="0">
@@ -20997,7 +21387,46 @@
       </p:sp>
       <p:sp>
         <p:nvSpPr>
-          <p:cNvPr id="59" name="Shape 57"/>
+          <p:cNvPr id="69" name="Text 67"/>
+          <p:cNvSpPr txBox="1"/>
+          <p:nvPr/>
+        </p:nvSpPr>
+        <p:spPr>
+          <a:xfrm>
+            <a:off x="10323576" y="2583619"/>
+            <a:ext cx="1115568" cy="265103"/>
+          </a:xfrm>
+          <a:prstGeom prst="rect">
+            <a:avLst/>
+          </a:prstGeom>
+          <a:noFill/>
+          <a:ln/>
+        </p:spPr>
+        <p:txBody>
+          <a:bodyPr wrap="square" lIns="0" tIns="0" rIns="0" bIns="0" rtlCol="0" anchor="t"/>
+          <a:lstStyle/>
+          <a:p>
+            <a:pPr algn="r" indent="0" marL="0">
+              <a:buNone/>
+            </a:pPr>
+            <a:r>
+              <a:rPr lang="en-US" sz="1300" dirty="0">
+                <a:solidFill>
+                  <a:srgbClr val="595959"/>
+                </a:solidFill>
+                <a:latin typeface="Inter" pitchFamily="34" charset="0"/>
+                <a:ea typeface="Inter" pitchFamily="34" charset="-122"/>
+                <a:cs typeface="Inter" pitchFamily="34" charset="-120"/>
+              </a:rPr>
+              <a:t>+23.8%</a:t>
+            </a:r>
+            <a:endParaRPr lang="en-US" sz="1300" dirty="0"/>
+          </a:p>
+        </p:txBody>
+      </p:sp>
+      <p:sp>
+        <p:nvSpPr>
+          <p:cNvPr id="70" name="Shape 68"/>
           <p:cNvSpPr/>
           <p:nvPr/>
         </p:nvSpPr>
@@ -21017,7 +21446,7 @@
       </p:sp>
       <p:sp>
         <p:nvSpPr>
-          <p:cNvPr id="60" name="Text 58"/>
+          <p:cNvPr id="71" name="Text 69"/>
           <p:cNvSpPr txBox="1"/>
           <p:nvPr/>
         </p:nvSpPr>
@@ -21056,7 +21485,7 @@
       </p:sp>
       <p:sp>
         <p:nvSpPr>
-          <p:cNvPr id="61" name="Text 59"/>
+          <p:cNvPr id="72" name="Text 70"/>
           <p:cNvSpPr txBox="1"/>
           <p:nvPr/>
         </p:nvSpPr>
@@ -21135,23 +21564,23 @@
       </p:sp>
       <p:sp>
         <p:nvSpPr>
-          <p:cNvPr id="62" name="Text 60"/>
-          <p:cNvSpPr txBox="1"/>
-          <p:nvPr/>
-        </p:nvSpPr>
-        <p:spPr>
-          <a:xfrm>
-            <a:off x="10323576" y="2931566"/>
-            <a:ext cx="1115568" cy="828446"/>
-          </a:xfrm>
-          <a:prstGeom prst="rect">
-            <a:avLst/>
-          </a:prstGeom>
-          <a:noFill/>
-          <a:ln/>
-        </p:spPr>
-        <p:txBody>
-          <a:bodyPr wrap="square" lIns="0" tIns="0" rIns="0" bIns="0" rtlCol="0" anchor="ctr"/>
+          <p:cNvPr id="73" name="Text 71"/>
+          <p:cNvSpPr txBox="1"/>
+          <p:nvPr/>
+        </p:nvSpPr>
+        <p:spPr>
+          <a:xfrm>
+            <a:off x="10323576" y="3030980"/>
+            <a:ext cx="1115568" cy="414223"/>
+          </a:xfrm>
+          <a:prstGeom prst="rect">
+            <a:avLst/>
+          </a:prstGeom>
+          <a:noFill/>
+          <a:ln/>
+        </p:spPr>
+        <p:txBody>
+          <a:bodyPr wrap="square" lIns="0" tIns="0" rIns="0" bIns="0" rtlCol="0" anchor="b"/>
           <a:lstStyle/>
           <a:p>
             <a:pPr algn="r" indent="0" marL="0">
@@ -21174,7 +21603,46 @@
       </p:sp>
       <p:sp>
         <p:nvSpPr>
-          <p:cNvPr id="63" name="Shape 61"/>
+          <p:cNvPr id="74" name="Text 72"/>
+          <p:cNvSpPr txBox="1"/>
+          <p:nvPr/>
+        </p:nvSpPr>
+        <p:spPr>
+          <a:xfrm>
+            <a:off x="10323576" y="3412065"/>
+            <a:ext cx="1115568" cy="265103"/>
+          </a:xfrm>
+          <a:prstGeom prst="rect">
+            <a:avLst/>
+          </a:prstGeom>
+          <a:noFill/>
+          <a:ln/>
+        </p:spPr>
+        <p:txBody>
+          <a:bodyPr wrap="square" lIns="0" tIns="0" rIns="0" bIns="0" rtlCol="0" anchor="t"/>
+          <a:lstStyle/>
+          <a:p>
+            <a:pPr algn="r" indent="0" marL="0">
+              <a:buNone/>
+            </a:pPr>
+            <a:r>
+              <a:rPr lang="en-US" sz="1300" dirty="0">
+                <a:solidFill>
+                  <a:srgbClr val="595959"/>
+                </a:solidFill>
+                <a:latin typeface="Inter" pitchFamily="34" charset="0"/>
+                <a:ea typeface="Inter" pitchFamily="34" charset="-122"/>
+                <a:cs typeface="Inter" pitchFamily="34" charset="-120"/>
+              </a:rPr>
+              <a:t>+17.4%</a:t>
+            </a:r>
+            <a:endParaRPr lang="en-US" sz="1300" dirty="0"/>
+          </a:p>
+        </p:txBody>
+      </p:sp>
+      <p:sp>
+        <p:nvSpPr>
+          <p:cNvPr id="75" name="Shape 73"/>
           <p:cNvSpPr/>
           <p:nvPr/>
         </p:nvSpPr>
@@ -21194,7 +21662,7 @@
       </p:sp>
       <p:sp>
         <p:nvSpPr>
-          <p:cNvPr id="64" name="Shape 62"/>
+          <p:cNvPr id="76" name="Shape 74"/>
           <p:cNvSpPr/>
           <p:nvPr/>
         </p:nvSpPr>
@@ -21214,7 +21682,7 @@
       </p:sp>
       <p:sp>
         <p:nvSpPr>
-          <p:cNvPr id="65" name="Text 63"/>
+          <p:cNvPr id="77" name="Text 75"/>
           <p:cNvSpPr txBox="1"/>
           <p:nvPr/>
         </p:nvSpPr>
@@ -21253,7 +21721,7 @@
       </p:sp>
       <p:sp>
         <p:nvSpPr>
-          <p:cNvPr id="66" name="Text 64"/>
+          <p:cNvPr id="78" name="Text 76"/>
           <p:cNvSpPr txBox="1"/>
           <p:nvPr/>
         </p:nvSpPr>
@@ -21332,23 +21800,23 @@
       </p:sp>
       <p:sp>
         <p:nvSpPr>
-          <p:cNvPr id="67" name="Text 65"/>
-          <p:cNvSpPr txBox="1"/>
-          <p:nvPr/>
-        </p:nvSpPr>
-        <p:spPr>
-          <a:xfrm>
-            <a:off x="10323576" y="3760013"/>
-            <a:ext cx="1115568" cy="828446"/>
-          </a:xfrm>
-          <a:prstGeom prst="rect">
-            <a:avLst/>
-          </a:prstGeom>
-          <a:noFill/>
-          <a:ln/>
-        </p:spPr>
-        <p:txBody>
-          <a:bodyPr wrap="square" lIns="0" tIns="0" rIns="0" bIns="0" rtlCol="0" anchor="ctr"/>
+          <p:cNvPr id="79" name="Text 77"/>
+          <p:cNvSpPr txBox="1"/>
+          <p:nvPr/>
+        </p:nvSpPr>
+        <p:spPr>
+          <a:xfrm>
+            <a:off x="10323576" y="3859426"/>
+            <a:ext cx="1115568" cy="414223"/>
+          </a:xfrm>
+          <a:prstGeom prst="rect">
+            <a:avLst/>
+          </a:prstGeom>
+          <a:noFill/>
+          <a:ln/>
+        </p:spPr>
+        <p:txBody>
+          <a:bodyPr wrap="square" lIns="0" tIns="0" rIns="0" bIns="0" rtlCol="0" anchor="b"/>
           <a:lstStyle/>
           <a:p>
             <a:pPr algn="r" indent="0" marL="0">
@@ -21371,7 +21839,46 @@
       </p:sp>
       <p:sp>
         <p:nvSpPr>
-          <p:cNvPr id="68" name="Text 66"/>
+          <p:cNvPr id="80" name="Text 78"/>
+          <p:cNvSpPr txBox="1"/>
+          <p:nvPr/>
+        </p:nvSpPr>
+        <p:spPr>
+          <a:xfrm>
+            <a:off x="10323576" y="4240512"/>
+            <a:ext cx="1115568" cy="265103"/>
+          </a:xfrm>
+          <a:prstGeom prst="rect">
+            <a:avLst/>
+          </a:prstGeom>
+          <a:noFill/>
+          <a:ln/>
+        </p:spPr>
+        <p:txBody>
+          <a:bodyPr wrap="square" lIns="0" tIns="0" rIns="0" bIns="0" rtlCol="0" anchor="t"/>
+          <a:lstStyle/>
+          <a:p>
+            <a:pPr algn="r" indent="0" marL="0">
+              <a:buNone/>
+            </a:pPr>
+            <a:r>
+              <a:rPr lang="en-US" sz="1300" dirty="0">
+                <a:solidFill>
+                  <a:srgbClr val="595959"/>
+                </a:solidFill>
+                <a:latin typeface="Inter" pitchFamily="34" charset="0"/>
+                <a:ea typeface="Inter" pitchFamily="34" charset="-122"/>
+                <a:cs typeface="Inter" pitchFamily="34" charset="-120"/>
+              </a:rPr>
+              <a:t>+62.3%</a:t>
+            </a:r>
+            <a:endParaRPr lang="en-US" sz="1300" dirty="0"/>
+          </a:p>
+        </p:txBody>
+      </p:sp>
+      <p:sp>
+        <p:nvSpPr>
+          <p:cNvPr id="81" name="Text 79"/>
           <p:cNvSpPr txBox="1"/>
           <p:nvPr/>
         </p:nvSpPr>
@@ -21410,7 +21917,7 @@
       </p:sp>
       <p:sp>
         <p:nvSpPr>
-          <p:cNvPr id="69" name="Text 67"/>
+          <p:cNvPr id="82" name="Text 80"/>
           <p:cNvSpPr txBox="1"/>
           <p:nvPr/>
         </p:nvSpPr>
@@ -21489,23 +21996,23 @@
       </p:sp>
       <p:sp>
         <p:nvSpPr>
-          <p:cNvPr id="70" name="Text 68"/>
-          <p:cNvSpPr txBox="1"/>
-          <p:nvPr/>
-        </p:nvSpPr>
-        <p:spPr>
-          <a:xfrm>
-            <a:off x="10323576" y="4588459"/>
-            <a:ext cx="1115568" cy="828446"/>
-          </a:xfrm>
-          <a:prstGeom prst="rect">
-            <a:avLst/>
-          </a:prstGeom>
-          <a:noFill/>
-          <a:ln/>
-        </p:spPr>
-        <p:txBody>
-          <a:bodyPr wrap="square" lIns="0" tIns="0" rIns="0" bIns="0" rtlCol="0" anchor="ctr"/>
+          <p:cNvPr id="83" name="Text 81"/>
+          <p:cNvSpPr txBox="1"/>
+          <p:nvPr/>
+        </p:nvSpPr>
+        <p:spPr>
+          <a:xfrm>
+            <a:off x="10323576" y="4687873"/>
+            <a:ext cx="1115568" cy="414223"/>
+          </a:xfrm>
+          <a:prstGeom prst="rect">
+            <a:avLst/>
+          </a:prstGeom>
+          <a:noFill/>
+          <a:ln/>
+        </p:spPr>
+        <p:txBody>
+          <a:bodyPr wrap="square" lIns="0" tIns="0" rIns="0" bIns="0" rtlCol="0" anchor="b"/>
           <a:lstStyle/>
           <a:p>
             <a:pPr algn="r" indent="0" marL="0">
@@ -21528,7 +22035,46 @@
       </p:sp>
       <p:sp>
         <p:nvSpPr>
-          <p:cNvPr id="71" name="Shape 69"/>
+          <p:cNvPr id="84" name="Text 82"/>
+          <p:cNvSpPr txBox="1"/>
+          <p:nvPr/>
+        </p:nvSpPr>
+        <p:spPr>
+          <a:xfrm>
+            <a:off x="10323576" y="5068958"/>
+            <a:ext cx="1115568" cy="265103"/>
+          </a:xfrm>
+          <a:prstGeom prst="rect">
+            <a:avLst/>
+          </a:prstGeom>
+          <a:noFill/>
+          <a:ln/>
+        </p:spPr>
+        <p:txBody>
+          <a:bodyPr wrap="square" lIns="0" tIns="0" rIns="0" bIns="0" rtlCol="0" anchor="t"/>
+          <a:lstStyle/>
+          <a:p>
+            <a:pPr algn="r" indent="0" marL="0">
+              <a:buNone/>
+            </a:pPr>
+            <a:r>
+              <a:rPr lang="en-US" sz="1300" dirty="0">
+                <a:solidFill>
+                  <a:srgbClr val="595959"/>
+                </a:solidFill>
+                <a:latin typeface="Inter" pitchFamily="34" charset="0"/>
+                <a:ea typeface="Inter" pitchFamily="34" charset="-122"/>
+                <a:cs typeface="Inter" pitchFamily="34" charset="-120"/>
+              </a:rPr>
+              <a:t>+29.2%</a:t>
+            </a:r>
+            <a:endParaRPr lang="en-US" sz="1300" dirty="0"/>
+          </a:p>
+        </p:txBody>
+      </p:sp>
+      <p:sp>
+        <p:nvSpPr>
+          <p:cNvPr id="85" name="Shape 83"/>
           <p:cNvSpPr/>
           <p:nvPr/>
         </p:nvSpPr>
@@ -21548,7 +22094,7 @@
       </p:sp>
       <p:sp>
         <p:nvSpPr>
-          <p:cNvPr id="72" name="Text 70"/>
+          <p:cNvPr id="86" name="Text 84"/>
           <p:cNvSpPr txBox="1"/>
           <p:nvPr/>
         </p:nvSpPr>
@@ -21587,7 +22133,7 @@
       </p:sp>
       <p:sp>
         <p:nvSpPr>
-          <p:cNvPr id="73" name="Text 71"/>
+          <p:cNvPr id="87" name="Text 85"/>
           <p:cNvSpPr txBox="1"/>
           <p:nvPr/>
         </p:nvSpPr>
@@ -21666,23 +22212,23 @@
       </p:sp>
       <p:sp>
         <p:nvSpPr>
-          <p:cNvPr id="74" name="Text 72"/>
-          <p:cNvSpPr txBox="1"/>
-          <p:nvPr/>
-        </p:nvSpPr>
-        <p:spPr>
-          <a:xfrm>
-            <a:off x="10323576" y="5416906"/>
-            <a:ext cx="1115568" cy="828446"/>
-          </a:xfrm>
-          <a:prstGeom prst="rect">
-            <a:avLst/>
-          </a:prstGeom>
-          <a:noFill/>
-          <a:ln/>
-        </p:spPr>
-        <p:txBody>
-          <a:bodyPr wrap="square" lIns="0" tIns="0" rIns="0" bIns="0" rtlCol="0" anchor="ctr"/>
+          <p:cNvPr id="88" name="Text 86"/>
+          <p:cNvSpPr txBox="1"/>
+          <p:nvPr/>
+        </p:nvSpPr>
+        <p:spPr>
+          <a:xfrm>
+            <a:off x="10323576" y="5516319"/>
+            <a:ext cx="1115568" cy="414223"/>
+          </a:xfrm>
+          <a:prstGeom prst="rect">
+            <a:avLst/>
+          </a:prstGeom>
+          <a:noFill/>
+          <a:ln/>
+        </p:spPr>
+        <p:txBody>
+          <a:bodyPr wrap="square" lIns="0" tIns="0" rIns="0" bIns="0" rtlCol="0" anchor="b"/>
           <a:lstStyle/>
           <a:p>
             <a:pPr algn="r" indent="0" marL="0">
@@ -21700,6 +22246,45 @@
               <a:t>+$84K</a:t>
             </a:r>
             <a:endParaRPr lang="en-US" sz="1600" dirty="0"/>
+          </a:p>
+        </p:txBody>
+      </p:sp>
+      <p:sp>
+        <p:nvSpPr>
+          <p:cNvPr id="89" name="Text 87"/>
+          <p:cNvSpPr txBox="1"/>
+          <p:nvPr/>
+        </p:nvSpPr>
+        <p:spPr>
+          <a:xfrm>
+            <a:off x="10323576" y="5897405"/>
+            <a:ext cx="1115568" cy="265103"/>
+          </a:xfrm>
+          <a:prstGeom prst="rect">
+            <a:avLst/>
+          </a:prstGeom>
+          <a:noFill/>
+          <a:ln/>
+        </p:spPr>
+        <p:txBody>
+          <a:bodyPr wrap="square" lIns="0" tIns="0" rIns="0" bIns="0" rtlCol="0" anchor="t"/>
+          <a:lstStyle/>
+          <a:p>
+            <a:pPr algn="r" indent="0" marL="0">
+              <a:buNone/>
+            </a:pPr>
+            <a:r>
+              <a:rPr lang="en-US" sz="1300" dirty="0">
+                <a:solidFill>
+                  <a:srgbClr val="595959"/>
+                </a:solidFill>
+                <a:latin typeface="Inter" pitchFamily="34" charset="0"/>
+                <a:ea typeface="Inter" pitchFamily="34" charset="-122"/>
+                <a:cs typeface="Inter" pitchFamily="34" charset="-120"/>
+              </a:rPr>
+              <a:t>+119.4%</a:t>
+            </a:r>
+            <a:endParaRPr lang="en-US" sz="1300" dirty="0"/>
           </a:p>
         </p:txBody>
       </p:sp>

</xml_diff>